<commit_message>
pptx styled: house palette, title rules, numbers, styled table
Blue rule under every title, consistent Segoe UI in ink with blue
equations and muted captions, slide numbers, a styled title slide
(accent band, muted byline), and the timeline table with a bold blue
date column and zebra rows. Same editable structure.

Co-Authored-By: Claude Fable 5 <noreply@anthropic.com>
</commit_message>
<xml_diff>
--- a/docs/slides/deck_week.pptx
+++ b/docs/slides/deck_week.pptx
@@ -4937,8 +4937,8 @@
         </p:nvSpPr>
         <p:spPr>
           <a:xfrm>
-            <a:off x="914400" y="2377440"/>
-            <a:ext cx="10332720" cy="1645920"/>
+            <a:off x="11430000" y="6446520"/>
+            <a:ext cx="640080" cy="320040"/>
           </a:xfrm>
           <a:prstGeom prst="rect">
             <a:avLst/>
@@ -4952,26 +4952,118 @@
           <a:lstStyle/>
           <a:p>
             <a:pPr>
-              <a:defRPr sz="3200" b="1">
+              <a:defRPr sz="1200" b="0">
+                <a:solidFill>
+                  <a:srgbClr val="6B7280"/>
+                </a:solidFill>
+                <a:latin typeface="Segoe UI"/>
+              </a:defRPr>
+            </a:pPr>
+            <a:r>
+              <a:t>1</a:t>
+            </a:r>
+          </a:p>
+        </p:txBody>
+      </p:sp>
+      <p:sp>
+        <p:nvSpPr>
+          <p:cNvPr id="3" name="Rectangle 2"/>
+          <p:cNvSpPr/>
+          <p:nvPr/>
+        </p:nvSpPr>
+        <p:spPr>
+          <a:xfrm>
+            <a:off x="0" y="2103120"/>
+            <a:ext cx="12188952" cy="38100"/>
+          </a:xfrm>
+          <a:prstGeom prst="rect">
+            <a:avLst/>
+          </a:prstGeom>
+          <a:solidFill>
+            <a:srgbClr val="0072B2"/>
+          </a:solidFill>
+          <a:ln>
+            <a:noFill/>
+          </a:ln>
+          <a:effectLst/>
+        </p:spPr>
+        <p:style>
+          <a:lnRef idx="1">
+            <a:schemeClr val="accent1"/>
+          </a:lnRef>
+          <a:fillRef idx="3">
+            <a:schemeClr val="accent1"/>
+          </a:fillRef>
+          <a:effectRef idx="2">
+            <a:schemeClr val="accent1"/>
+          </a:effectRef>
+          <a:fontRef idx="minor">
+            <a:schemeClr val="lt1"/>
+          </a:fontRef>
+        </p:style>
+        <p:txBody>
+          <a:bodyPr rtlCol="0" anchor="ctr"/>
+          <a:lstStyle/>
+          <a:p>
+            <a:pPr algn="ctr"/>
+          </a:p>
+        </p:txBody>
+      </p:sp>
+      <p:sp>
+        <p:nvSpPr>
+          <p:cNvPr id="4" name="TextBox 3"/>
+          <p:cNvSpPr txBox="1"/>
+          <p:nvPr/>
+        </p:nvSpPr>
+        <p:spPr>
+          <a:xfrm>
+            <a:off x="914400" y="2468880"/>
+            <a:ext cx="10332720" cy="2011680"/>
+          </a:xfrm>
+          <a:prstGeom prst="rect">
+            <a:avLst/>
+          </a:prstGeom>
+          <a:noFill/>
+        </p:spPr>
+        <p:txBody>
+          <a:bodyPr wrap="none">
+            <a:spAutoFit/>
+          </a:bodyPr>
+          <a:lstStyle/>
+          <a:p>
+            <a:pPr>
+              <a:defRPr sz="3400" b="1">
                 <a:solidFill>
                   <a:srgbClr val="1A1A1A"/>
                 </a:solidFill>
+                <a:latin typeface="Segoe UI"/>
               </a:defRPr>
             </a:pPr>
             <a:r>
               <a:t>Expressive Performance as a Gaussian Process on a Musical Score Graph</a:t>
             </a:r>
+          </a:p>
+          <a:p>
+            <a:pPr>
+              <a:defRPr sz="1200" b="0">
+                <a:solidFill>
+                  <a:srgbClr val="1A1A1A"/>
+                </a:solidFill>
+                <a:latin typeface="Segoe UI"/>
+              </a:defRPr>
+            </a:pPr>
           </a:p>
           <a:p>
             <a:pPr>
               <a:defRPr sz="1800" b="0">
                 <a:solidFill>
-                  <a:srgbClr val="1A1A1A"/>
-                </a:solidFill>
+                  <a:srgbClr val="6B7280"/>
+                </a:solidFill>
+                <a:latin typeface="Segoe UI"/>
               </a:defRPr>
             </a:pPr>
             <a:r>
-              <a:t>Raynaldi Lalang — Kyoto University — October 2026</a:t>
+              <a:t>Raynaldi Lalang   ·   Kyoto University   ·   October 2026</a:t>
             </a:r>
           </a:p>
         </p:txBody>
@@ -5002,8 +5094,8 @@
         </p:nvSpPr>
         <p:spPr>
           <a:xfrm>
-            <a:off x="411480" y="228600"/>
-            <a:ext cx="11338560" cy="685800"/>
+            <a:off x="11430000" y="6446520"/>
+            <a:ext cx="640080" cy="320040"/>
           </a:xfrm>
           <a:prstGeom prst="rect">
             <a:avLst/>
@@ -5017,14 +5109,15 @@
           <a:lstStyle/>
           <a:p>
             <a:pPr>
-              <a:defRPr sz="2800" b="1">
-                <a:solidFill>
-                  <a:srgbClr val="1A1A1A"/>
-                </a:solidFill>
+              <a:defRPr sz="1200" b="0">
+                <a:solidFill>
+                  <a:srgbClr val="6B7280"/>
+                </a:solidFill>
+                <a:latin typeface="Segoe UI"/>
               </a:defRPr>
             </a:pPr>
             <a:r>
-              <a:t>Phase 1: results (piano, ASAP)</a:t>
+              <a:t>10</a:t>
             </a:r>
           </a:p>
         </p:txBody>
@@ -5037,6 +5130,86 @@
         </p:nvSpPr>
         <p:spPr>
           <a:xfrm>
+            <a:off x="411480" y="228600"/>
+            <a:ext cx="11338560" cy="685800"/>
+          </a:xfrm>
+          <a:prstGeom prst="rect">
+            <a:avLst/>
+          </a:prstGeom>
+          <a:noFill/>
+        </p:spPr>
+        <p:txBody>
+          <a:bodyPr wrap="none">
+            <a:spAutoFit/>
+          </a:bodyPr>
+          <a:lstStyle/>
+          <a:p>
+            <a:pPr>
+              <a:defRPr sz="2800" b="1">
+                <a:solidFill>
+                  <a:srgbClr val="1A1A1A"/>
+                </a:solidFill>
+                <a:latin typeface="Segoe UI"/>
+              </a:defRPr>
+            </a:pPr>
+            <a:r>
+              <a:t>Phase 1: results (piano, ASAP)</a:t>
+            </a:r>
+          </a:p>
+        </p:txBody>
+      </p:sp>
+      <p:sp>
+        <p:nvSpPr>
+          <p:cNvPr id="4" name="Rectangle 3"/>
+          <p:cNvSpPr/>
+          <p:nvPr/>
+        </p:nvSpPr>
+        <p:spPr>
+          <a:xfrm>
+            <a:off x="457200" y="896112"/>
+            <a:ext cx="11247120" cy="27940"/>
+          </a:xfrm>
+          <a:prstGeom prst="rect">
+            <a:avLst/>
+          </a:prstGeom>
+          <a:solidFill>
+            <a:srgbClr val="0072B2"/>
+          </a:solidFill>
+          <a:ln>
+            <a:noFill/>
+          </a:ln>
+          <a:effectLst/>
+        </p:spPr>
+        <p:style>
+          <a:lnRef idx="1">
+            <a:schemeClr val="accent1"/>
+          </a:lnRef>
+          <a:fillRef idx="3">
+            <a:schemeClr val="accent1"/>
+          </a:fillRef>
+          <a:effectRef idx="2">
+            <a:schemeClr val="accent1"/>
+          </a:effectRef>
+          <a:fontRef idx="minor">
+            <a:schemeClr val="lt1"/>
+          </a:fontRef>
+        </p:style>
+        <p:txBody>
+          <a:bodyPr rtlCol="0" anchor="ctr"/>
+          <a:lstStyle/>
+          <a:p>
+            <a:pPr algn="ctr"/>
+          </a:p>
+        </p:txBody>
+      </p:sp>
+      <p:sp>
+        <p:nvSpPr>
+          <p:cNvPr id="5" name="TextBox 4"/>
+          <p:cNvSpPr txBox="1"/>
+          <p:nvPr/>
+        </p:nvSpPr>
+        <p:spPr>
+          <a:xfrm>
             <a:off x="822960" y="1097280"/>
             <a:ext cx="10607040" cy="4389120"/>
           </a:xfrm>
@@ -5053,61 +5226,65 @@
           <a:p>
             <a:pPr>
               <a:spcAft>
-                <a:spcPts val="800"/>
+                <a:spcPts val="1000"/>
               </a:spcAft>
-              <a:defRPr sz="2000">
+              <a:defRPr sz="2000" b="0">
                 <a:solidFill>
                   <a:srgbClr val="1A1A1A"/>
                 </a:solidFill>
+                <a:latin typeface="Segoe UI"/>
               </a:defRPr>
             </a:pPr>
             <a:r>
-              <a:t>• Preregistered, scored once on 20 untouched pieces, against the two-stage pipeline the model contains.</a:t>
+              <a:t>•  Preregistered, scored once on 20 untouched pieces, against the two-stage pipeline the model contains.</a:t>
             </a:r>
           </a:p>
           <a:p>
             <a:pPr>
               <a:spcAft>
-                <a:spcPts val="800"/>
+                <a:spcPts val="1000"/>
               </a:spcAft>
-              <a:defRPr sz="2000">
+              <a:defRPr sz="2000" b="0">
                 <a:solidFill>
                   <a:srgbClr val="1A1A1A"/>
                 </a:solidFill>
+                <a:latin typeface="Segoe UI"/>
               </a:defRPr>
             </a:pPr>
             <a:r>
-              <a:t>• Accuracy: RMSE 0.376 vs 0.393 (pooled over the three channels), paired per-piece difference significant.</a:t>
+              <a:t>•  Accuracy: RMSE 0.376 vs 0.393 (pooled over the three channels), paired per-piece difference significant.</a:t>
             </a:r>
           </a:p>
           <a:p>
             <a:pPr>
               <a:spcAft>
-                <a:spcPts val="800"/>
+                <a:spcPts val="1000"/>
               </a:spcAft>
-              <a:defRPr sz="2000">
+              <a:defRPr sz="2000" b="0">
                 <a:solidFill>
                   <a:srgbClr val="1A1A1A"/>
                 </a:solidFill>
+                <a:latin typeface="Segoe UI"/>
               </a:defRPr>
             </a:pPr>
             <a:r>
-              <a:t>• Calibration: the graph's log-score contribution significant; coverage 0.925 at nominal 0.90.</a:t>
+              <a:t>•  Calibration: the graph's log-score contribution significant; coverage 0.925 at nominal 0.90.</a:t>
             </a:r>
           </a:p>
           <a:p>
             <a:pPr>
               <a:spcAft>
-                <a:spcPts val="800"/>
+                <a:spcPts val="1000"/>
               </a:spcAft>
-              <a:defRPr sz="2000">
+              <a:defRPr sz="2000" b="0">
                 <a:solidFill>
                   <a:srgbClr val="1A1A1A"/>
                 </a:solidFill>
+                <a:latin typeface="Segoe UI"/>
               </a:defRPr>
             </a:pPr>
             <a:r>
-              <a:t>• Attribution: the features carry the mean, the graph carries the calibration.</a:t>
+              <a:t>•  Attribution: the features carry the mean, the graph carries the calibration.</a:t>
             </a:r>
           </a:p>
         </p:txBody>
@@ -5138,8 +5315,8 @@
         </p:nvSpPr>
         <p:spPr>
           <a:xfrm>
-            <a:off x="411480" y="228600"/>
-            <a:ext cx="11338560" cy="685800"/>
+            <a:off x="11430000" y="6446520"/>
+            <a:ext cx="640080" cy="320040"/>
           </a:xfrm>
           <a:prstGeom prst="rect">
             <a:avLst/>
@@ -5153,14 +5330,15 @@
           <a:lstStyle/>
           <a:p>
             <a:pPr>
-              <a:defRPr sz="2800" b="1">
-                <a:solidFill>
-                  <a:srgbClr val="1A1A1A"/>
-                </a:solidFill>
+              <a:defRPr sz="1200" b="0">
+                <a:solidFill>
+                  <a:srgbClr val="6B7280"/>
+                </a:solidFill>
+                <a:latin typeface="Segoe UI"/>
               </a:defRPr>
             </a:pPr>
             <a:r>
-              <a:t>Phase 2: from audio to the cents curve</a:t>
+              <a:t>11</a:t>
             </a:r>
           </a:p>
         </p:txBody>
@@ -5173,8 +5351,8 @@
         </p:nvSpPr>
         <p:spPr>
           <a:xfrm>
-            <a:off x="822960" y="1097280"/>
-            <a:ext cx="10515600" cy="640080"/>
+            <a:off x="411480" y="228600"/>
+            <a:ext cx="11338560" cy="685800"/>
           </a:xfrm>
           <a:prstGeom prst="rect">
             <a:avLst/>
@@ -5188,10 +5366,91 @@
           <a:lstStyle/>
           <a:p>
             <a:pPr>
-              <a:defRPr sz="2000">
+              <a:defRPr sz="2800" b="1">
+                <a:solidFill>
+                  <a:srgbClr val="1A1A1A"/>
+                </a:solidFill>
+                <a:latin typeface="Segoe UI"/>
+              </a:defRPr>
+            </a:pPr>
+            <a:r>
+              <a:t>Phase 2: from audio to the cents curve</a:t>
+            </a:r>
+          </a:p>
+        </p:txBody>
+      </p:sp>
+      <p:sp>
+        <p:nvSpPr>
+          <p:cNvPr id="4" name="Rectangle 3"/>
+          <p:cNvSpPr/>
+          <p:nvPr/>
+        </p:nvSpPr>
+        <p:spPr>
+          <a:xfrm>
+            <a:off x="457200" y="896112"/>
+            <a:ext cx="11247120" cy="27940"/>
+          </a:xfrm>
+          <a:prstGeom prst="rect">
+            <a:avLst/>
+          </a:prstGeom>
+          <a:solidFill>
+            <a:srgbClr val="0072B2"/>
+          </a:solidFill>
+          <a:ln>
+            <a:noFill/>
+          </a:ln>
+          <a:effectLst/>
+        </p:spPr>
+        <p:style>
+          <a:lnRef idx="1">
+            <a:schemeClr val="accent1"/>
+          </a:lnRef>
+          <a:fillRef idx="3">
+            <a:schemeClr val="accent1"/>
+          </a:fillRef>
+          <a:effectRef idx="2">
+            <a:schemeClr val="accent1"/>
+          </a:effectRef>
+          <a:fontRef idx="minor">
+            <a:schemeClr val="lt1"/>
+          </a:fontRef>
+        </p:style>
+        <p:txBody>
+          <a:bodyPr rtlCol="0" anchor="ctr"/>
+          <a:lstStyle/>
+          <a:p>
+            <a:pPr algn="ctr"/>
+          </a:p>
+        </p:txBody>
+      </p:sp>
+      <p:sp>
+        <p:nvSpPr>
+          <p:cNvPr id="5" name="TextBox 4"/>
+          <p:cNvSpPr txBox="1"/>
+          <p:nvPr/>
+        </p:nvSpPr>
+        <p:spPr>
+          <a:xfrm>
+            <a:off x="822960" y="1097280"/>
+            <a:ext cx="10515600" cy="640080"/>
+          </a:xfrm>
+          <a:prstGeom prst="rect">
+            <a:avLst/>
+          </a:prstGeom>
+          <a:noFill/>
+        </p:spPr>
+        <p:txBody>
+          <a:bodyPr wrap="none">
+            <a:spAutoFit/>
+          </a:bodyPr>
+          <a:lstStyle/>
+          <a:p>
+            <a:pPr>
+              <a:defRPr sz="2000" b="0">
                 <a:solidFill>
                   <a:srgbClr val="0072B2"/>
                 </a:solidFill>
+                <a:latin typeface="Segoe UI"/>
               </a:defRPr>
             </a:pPr>
             <a:r>
@@ -5202,7 +5461,7 @@
       </p:sp>
       <p:sp>
         <p:nvSpPr>
-          <p:cNvPr id="4" name="TextBox 3"/>
+          <p:cNvPr id="6" name="TextBox 5"/>
           <p:cNvSpPr txBox="1"/>
           <p:nvPr/>
         </p:nvSpPr>
@@ -5224,46 +5483,49 @@
           <a:p>
             <a:pPr>
               <a:spcAft>
-                <a:spcPts val="800"/>
+                <a:spcPts val="1000"/>
               </a:spcAft>
-              <a:defRPr sz="2000">
+              <a:defRPr sz="2000" b="0">
                 <a:solidFill>
                   <a:srgbClr val="1A1A1A"/>
                 </a:solidFill>
+                <a:latin typeface="Segoe UI"/>
               </a:defRPr>
             </a:pPr>
             <a:r>
-              <a:t>• A pitch tracker gives frames: time, f₀, voicing confidence.</a:t>
+              <a:t>•  A pitch tracker gives frames: time, f₀, voicing confidence.</a:t>
             </a:r>
           </a:p>
           <a:p>
             <a:pPr>
               <a:spcAft>
-                <a:spcPts val="800"/>
+                <a:spcPts val="1000"/>
               </a:spcAft>
-              <a:defRPr sz="2000">
+              <a:defRPr sz="2000" b="0">
                 <a:solidFill>
                   <a:srgbClr val="1A1A1A"/>
                 </a:solidFill>
+                <a:latin typeface="Segoe UI"/>
               </a:defRPr>
             </a:pPr>
             <a:r>
-              <a:t>• Frame rule: voiced, confidence above the track's lowest quintile, at least 4 frames per note.</a:t>
+              <a:t>•  Frame rule: voiced, confidence above the track's lowest quintile, at least 4 frames per note.</a:t>
             </a:r>
           </a:p>
           <a:p>
             <a:pPr>
               <a:spcAft>
-                <a:spcPts val="800"/>
+                <a:spcPts val="1000"/>
               </a:spcAft>
-              <a:defRPr sz="2000">
+              <a:defRPr sz="2000" b="0">
                 <a:solidFill>
                   <a:srgbClr val="1A1A1A"/>
                 </a:solidFill>
+                <a:latin typeface="Segoe UI"/>
               </a:defRPr>
             </a:pPr>
             <a:r>
-              <a:t>• Two curves per note — tracked: pYIN, run by us; ground truth: the corpus's own annotation of the same stem. Cleaner, but still a measurement.</a:t>
+              <a:t>•  Two curves per note — tracked: pYIN, run by us; ground truth: the corpus's own annotation of the same stem. Cleaner, but still a measurement.</a:t>
             </a:r>
           </a:p>
         </p:txBody>
@@ -5294,8 +5556,8 @@
         </p:nvSpPr>
         <p:spPr>
           <a:xfrm>
-            <a:off x="411480" y="228600"/>
-            <a:ext cx="11338560" cy="685800"/>
+            <a:off x="11430000" y="6446520"/>
+            <a:ext cx="640080" cy="320040"/>
           </a:xfrm>
           <a:prstGeom prst="rect">
             <a:avLst/>
@@ -5309,14 +5571,15 @@
           <a:lstStyle/>
           <a:p>
             <a:pPr>
-              <a:defRPr sz="2800" b="1">
-                <a:solidFill>
-                  <a:srgbClr val="1A1A1A"/>
-                </a:solidFill>
+              <a:defRPr sz="1200" b="0">
+                <a:solidFill>
+                  <a:srgbClr val="6B7280"/>
+                </a:solidFill>
+                <a:latin typeface="Segoe UI"/>
               </a:defRPr>
             </a:pPr>
             <a:r>
-              <a:t>Phase 2: the pitch-curve channels</a:t>
+              <a:t>12</a:t>
             </a:r>
           </a:p>
         </p:txBody>
@@ -5329,6 +5592,86 @@
         </p:nvSpPr>
         <p:spPr>
           <a:xfrm>
+            <a:off x="411480" y="228600"/>
+            <a:ext cx="11338560" cy="685800"/>
+          </a:xfrm>
+          <a:prstGeom prst="rect">
+            <a:avLst/>
+          </a:prstGeom>
+          <a:noFill/>
+        </p:spPr>
+        <p:txBody>
+          <a:bodyPr wrap="none">
+            <a:spAutoFit/>
+          </a:bodyPr>
+          <a:lstStyle/>
+          <a:p>
+            <a:pPr>
+              <a:defRPr sz="2800" b="1">
+                <a:solidFill>
+                  <a:srgbClr val="1A1A1A"/>
+                </a:solidFill>
+                <a:latin typeface="Segoe UI"/>
+              </a:defRPr>
+            </a:pPr>
+            <a:r>
+              <a:t>Phase 2: the pitch-curve channels</a:t>
+            </a:r>
+          </a:p>
+        </p:txBody>
+      </p:sp>
+      <p:sp>
+        <p:nvSpPr>
+          <p:cNvPr id="4" name="Rectangle 3"/>
+          <p:cNvSpPr/>
+          <p:nvPr/>
+        </p:nvSpPr>
+        <p:spPr>
+          <a:xfrm>
+            <a:off x="457200" y="896112"/>
+            <a:ext cx="11247120" cy="27940"/>
+          </a:xfrm>
+          <a:prstGeom prst="rect">
+            <a:avLst/>
+          </a:prstGeom>
+          <a:solidFill>
+            <a:srgbClr val="0072B2"/>
+          </a:solidFill>
+          <a:ln>
+            <a:noFill/>
+          </a:ln>
+          <a:effectLst/>
+        </p:spPr>
+        <p:style>
+          <a:lnRef idx="1">
+            <a:schemeClr val="accent1"/>
+          </a:lnRef>
+          <a:fillRef idx="3">
+            <a:schemeClr val="accent1"/>
+          </a:fillRef>
+          <a:effectRef idx="2">
+            <a:schemeClr val="accent1"/>
+          </a:effectRef>
+          <a:fontRef idx="minor">
+            <a:schemeClr val="lt1"/>
+          </a:fontRef>
+        </p:style>
+        <p:txBody>
+          <a:bodyPr rtlCol="0" anchor="ctr"/>
+          <a:lstStyle/>
+          <a:p>
+            <a:pPr algn="ctr"/>
+          </a:p>
+        </p:txBody>
+      </p:sp>
+      <p:sp>
+        <p:nvSpPr>
+          <p:cNvPr id="5" name="TextBox 4"/>
+          <p:cNvSpPr txBox="1"/>
+          <p:nvPr/>
+        </p:nvSpPr>
+        <p:spPr>
+          <a:xfrm>
             <a:off x="822960" y="1097280"/>
             <a:ext cx="10607040" cy="4389120"/>
           </a:xfrm>
@@ -5345,76 +5688,81 @@
           <a:p>
             <a:pPr>
               <a:spcAft>
-                <a:spcPts val="800"/>
+                <a:spcPts val="1000"/>
               </a:spcAft>
-              <a:defRPr sz="2000">
+              <a:defRPr sz="2000" b="0">
                 <a:solidFill>
                   <a:srgbClr val="1A1A1A"/>
                 </a:solidFill>
+                <a:latin typeface="Segoe UI"/>
               </a:defRPr>
             </a:pPr>
             <a:r>
-              <a:t>• Within one note: a sustained level plus one oscillation. Three numbers describe it.</a:t>
+              <a:t>•  Within one note: a sustained level plus one oscillation. Three numbers describe it.</a:t>
             </a:r>
           </a:p>
           <a:p>
             <a:pPr>
               <a:spcAft>
-                <a:spcPts val="800"/>
+                <a:spcPts val="1000"/>
               </a:spcAft>
-              <a:defRPr sz="2000">
+              <a:defRPr sz="2000" b="0">
                 <a:solidFill>
                   <a:srgbClr val="1A1A1A"/>
                 </a:solidFill>
+                <a:latin typeface="Segoe UI"/>
               </a:defRPr>
             </a:pPr>
             <a:r>
-              <a:t>• Intonation c (cents): the sustained offset from the written pitch. c &gt; 0 sharp; 100 = a semitone.</a:t>
+              <a:t>•  Intonation c (cents): the sustained offset from the written pitch. c &gt; 0 sharp; 100 = a semitone.</a:t>
             </a:r>
           </a:p>
           <a:p>
             <a:pPr>
               <a:spcAft>
-                <a:spcPts val="800"/>
+                <a:spcPts val="1000"/>
               </a:spcAft>
-              <a:defRPr sz="2000">
+              <a:defRPr sz="2000" b="0">
                 <a:solidFill>
                   <a:srgbClr val="1A1A1A"/>
                 </a:solidFill>
+                <a:latin typeface="Segoe UI"/>
               </a:defRPr>
             </a:pPr>
             <a:r>
-              <a:t>• Vibrato extent γ (cents): the oscillation's amplitude.</a:t>
+              <a:t>•  Vibrato extent γ (cents): the oscillation's amplitude.</a:t>
             </a:r>
           </a:p>
           <a:p>
             <a:pPr>
               <a:spcAft>
-                <a:spcPts val="800"/>
+                <a:spcPts val="1000"/>
               </a:spcAft>
-              <a:defRPr sz="2000">
+              <a:defRPr sz="2000" b="0">
                 <a:solidFill>
                   <a:srgbClr val="1A1A1A"/>
                 </a:solidFill>
+                <a:latin typeface="Segoe UI"/>
               </a:defRPr>
             </a:pPr>
             <a:r>
-              <a:t>• Vibrato rate f (Hz): its frequency; vibrato lives at roughly 4–8 Hz.</a:t>
+              <a:t>•  Vibrato rate f (Hz): its frequency; vibrato lives at roughly 4–8 Hz.</a:t>
             </a:r>
           </a:p>
           <a:p>
             <a:pPr>
               <a:spcAft>
-                <a:spcPts val="800"/>
+                <a:spcPts val="1000"/>
               </a:spcAft>
-              <a:defRPr sz="2000">
+              <a:defRPr sz="2000" b="0">
                 <a:solidFill>
                   <a:srgbClr val="1A1A1A"/>
                 </a:solidFill>
+                <a:latin typeface="Segoe UI"/>
               </a:defRPr>
             </a:pPr>
             <a:r>
-              <a:t>• The bundle carries log γ, log f. No oscillation found: those cells are missing, c remains.</a:t>
+              <a:t>•  The bundle carries log γ, log f. No oscillation found: those cells are missing, c remains.</a:t>
             </a:r>
           </a:p>
         </p:txBody>
@@ -5445,8 +5793,8 @@
         </p:nvSpPr>
         <p:spPr>
           <a:xfrm>
-            <a:off x="411480" y="228600"/>
-            <a:ext cx="11338560" cy="685800"/>
+            <a:off x="11430000" y="6446520"/>
+            <a:ext cx="640080" cy="320040"/>
           </a:xfrm>
           <a:prstGeom prst="rect">
             <a:avLst/>
@@ -5460,21 +5808,102 @@
           <a:lstStyle/>
           <a:p>
             <a:pPr>
+              <a:defRPr sz="1200" b="0">
+                <a:solidFill>
+                  <a:srgbClr val="6B7280"/>
+                </a:solidFill>
+                <a:latin typeface="Segoe UI"/>
+              </a:defRPr>
+            </a:pPr>
+            <a:r>
+              <a:t>13</a:t>
+            </a:r>
+          </a:p>
+        </p:txBody>
+      </p:sp>
+      <p:sp>
+        <p:nvSpPr>
+          <p:cNvPr id="3" name="TextBox 2"/>
+          <p:cNvSpPr txBox="1"/>
+          <p:nvPr/>
+        </p:nvSpPr>
+        <p:spPr>
+          <a:xfrm>
+            <a:off x="411480" y="228600"/>
+            <a:ext cx="11338560" cy="685800"/>
+          </a:xfrm>
+          <a:prstGeom prst="rect">
+            <a:avLst/>
+          </a:prstGeom>
+          <a:noFill/>
+        </p:spPr>
+        <p:txBody>
+          <a:bodyPr wrap="none">
+            <a:spAutoFit/>
+          </a:bodyPr>
+          <a:lstStyle/>
+          <a:p>
+            <a:pPr>
               <a:defRPr sz="2800" b="1">
                 <a:solidFill>
                   <a:srgbClr val="1A1A1A"/>
                 </a:solidFill>
+                <a:latin typeface="Segoe UI"/>
               </a:defRPr>
             </a:pPr>
             <a:r>
               <a:t>Phase 2: what the data looks like</a:t>
             </a:r>
+          </a:p>
+        </p:txBody>
+      </p:sp>
+      <p:sp>
+        <p:nvSpPr>
+          <p:cNvPr id="4" name="Rectangle 3"/>
+          <p:cNvSpPr/>
+          <p:nvPr/>
+        </p:nvSpPr>
+        <p:spPr>
+          <a:xfrm>
+            <a:off x="457200" y="896112"/>
+            <a:ext cx="11247120" cy="27940"/>
+          </a:xfrm>
+          <a:prstGeom prst="rect">
+            <a:avLst/>
+          </a:prstGeom>
+          <a:solidFill>
+            <a:srgbClr val="0072B2"/>
+          </a:solidFill>
+          <a:ln>
+            <a:noFill/>
+          </a:ln>
+          <a:effectLst/>
+        </p:spPr>
+        <p:style>
+          <a:lnRef idx="1">
+            <a:schemeClr val="accent1"/>
+          </a:lnRef>
+          <a:fillRef idx="3">
+            <a:schemeClr val="accent1"/>
+          </a:fillRef>
+          <a:effectRef idx="2">
+            <a:schemeClr val="accent1"/>
+          </a:effectRef>
+          <a:fontRef idx="minor">
+            <a:schemeClr val="lt1"/>
+          </a:fontRef>
+        </p:style>
+        <p:txBody>
+          <a:bodyPr rtlCol="0" anchor="ctr"/>
+          <a:lstStyle/>
+          <a:p>
+            <a:pPr algn="ctr"/>
           </a:p>
         </p:txBody>
       </p:sp>
       <p:pic>
         <p:nvPicPr>
-          <p:cNvPr id="3" name="Picture 2" descr="phase2_frames_intro.png"/>
+          <p:cNvPr id="5" name="Picture 4" descr="phase2_frames_intro.png"/>
           <p:cNvPicPr>
             <a:picLocks noChangeAspect="1"/>
           </p:cNvPicPr>
@@ -5498,7 +5927,7 @@
       </p:pic>
       <p:sp>
         <p:nvSpPr>
-          <p:cNvPr id="4" name="TextBox 3"/>
+          <p:cNvPr id="6" name="TextBox 5"/>
           <p:cNvSpPr txBox="1"/>
           <p:nvPr/>
         </p:nvSpPr>
@@ -5519,10 +5948,11 @@
           <a:lstStyle/>
           <a:p>
             <a:pPr>
-              <a:defRPr sz="1300">
+              <a:defRPr sz="1300" b="0">
                 <a:solidFill>
                   <a:srgbClr val="6B7280"/>
                 </a:solidFill>
+                <a:latin typeface="Segoe UI"/>
               </a:defRPr>
             </a:pPr>
             <a:r>
@@ -5557,8 +5987,8 @@
         </p:nvSpPr>
         <p:spPr>
           <a:xfrm>
-            <a:off x="411480" y="228600"/>
-            <a:ext cx="11338560" cy="685800"/>
+            <a:off x="11430000" y="6446520"/>
+            <a:ext cx="640080" cy="320040"/>
           </a:xfrm>
           <a:prstGeom prst="rect">
             <a:avLst/>
@@ -5572,14 +6002,15 @@
           <a:lstStyle/>
           <a:p>
             <a:pPr>
-              <a:defRPr sz="2800" b="1">
-                <a:solidFill>
-                  <a:srgbClr val="1A1A1A"/>
-                </a:solidFill>
+              <a:defRPr sz="1200" b="0">
+                <a:solidFill>
+                  <a:srgbClr val="6B7280"/>
+                </a:solidFill>
+                <a:latin typeface="Segoe UI"/>
               </a:defRPr>
             </a:pPr>
             <a:r>
-              <a:t>Estimating the channels with a Gaussian process</a:t>
+              <a:t>14</a:t>
             </a:r>
           </a:p>
         </p:txBody>
@@ -5592,8 +6023,8 @@
         </p:nvSpPr>
         <p:spPr>
           <a:xfrm>
-            <a:off x="822960" y="1097280"/>
-            <a:ext cx="10515600" cy="640080"/>
+            <a:off x="411480" y="228600"/>
+            <a:ext cx="11338560" cy="685800"/>
           </a:xfrm>
           <a:prstGeom prst="rect">
             <a:avLst/>
@@ -5607,10 +6038,91 @@
           <a:lstStyle/>
           <a:p>
             <a:pPr>
-              <a:defRPr sz="2000">
+              <a:defRPr sz="2800" b="1">
+                <a:solidFill>
+                  <a:srgbClr val="1A1A1A"/>
+                </a:solidFill>
+                <a:latin typeface="Segoe UI"/>
+              </a:defRPr>
+            </a:pPr>
+            <a:r>
+              <a:t>Estimating the channels with a Gaussian process</a:t>
+            </a:r>
+          </a:p>
+        </p:txBody>
+      </p:sp>
+      <p:sp>
+        <p:nvSpPr>
+          <p:cNvPr id="4" name="Rectangle 3"/>
+          <p:cNvSpPr/>
+          <p:nvPr/>
+        </p:nvSpPr>
+        <p:spPr>
+          <a:xfrm>
+            <a:off x="457200" y="896112"/>
+            <a:ext cx="11247120" cy="27940"/>
+          </a:xfrm>
+          <a:prstGeom prst="rect">
+            <a:avLst/>
+          </a:prstGeom>
+          <a:solidFill>
+            <a:srgbClr val="0072B2"/>
+          </a:solidFill>
+          <a:ln>
+            <a:noFill/>
+          </a:ln>
+          <a:effectLst/>
+        </p:spPr>
+        <p:style>
+          <a:lnRef idx="1">
+            <a:schemeClr val="accent1"/>
+          </a:lnRef>
+          <a:fillRef idx="3">
+            <a:schemeClr val="accent1"/>
+          </a:fillRef>
+          <a:effectRef idx="2">
+            <a:schemeClr val="accent1"/>
+          </a:effectRef>
+          <a:fontRef idx="minor">
+            <a:schemeClr val="lt1"/>
+          </a:fontRef>
+        </p:style>
+        <p:txBody>
+          <a:bodyPr rtlCol="0" anchor="ctr"/>
+          <a:lstStyle/>
+          <a:p>
+            <a:pPr algn="ctr"/>
+          </a:p>
+        </p:txBody>
+      </p:sp>
+      <p:sp>
+        <p:nvSpPr>
+          <p:cNvPr id="5" name="TextBox 4"/>
+          <p:cNvSpPr txBox="1"/>
+          <p:nvPr/>
+        </p:nvSpPr>
+        <p:spPr>
+          <a:xfrm>
+            <a:off x="822960" y="1097280"/>
+            <a:ext cx="10515600" cy="640080"/>
+          </a:xfrm>
+          <a:prstGeom prst="rect">
+            <a:avLst/>
+          </a:prstGeom>
+          <a:noFill/>
+        </p:spPr>
+        <p:txBody>
+          <a:bodyPr wrap="none">
+            <a:spAutoFit/>
+          </a:bodyPr>
+          <a:lstStyle/>
+          <a:p>
+            <a:pPr>
+              <a:defRPr sz="2000" b="0">
                 <a:solidFill>
                   <a:srgbClr val="0072B2"/>
                 </a:solidFill>
+                <a:latin typeface="Segoe UI"/>
               </a:defRPr>
             </a:pPr>
             <a:r>
@@ -5621,7 +6133,7 @@
       </p:sp>
       <p:sp>
         <p:nvSpPr>
-          <p:cNvPr id="4" name="TextBox 3"/>
+          <p:cNvPr id="6" name="TextBox 5"/>
           <p:cNvSpPr txBox="1"/>
           <p:nvPr/>
         </p:nvSpPr>
@@ -5643,61 +6155,65 @@
           <a:p>
             <a:pPr>
               <a:spcAft>
-                <a:spcPts val="800"/>
+                <a:spcPts val="1000"/>
               </a:spcAft>
-              <a:defRPr sz="2000">
+              <a:defRPr sz="2000" b="0">
                 <a:solidFill>
                   <a:srgbClr val="1A1A1A"/>
                 </a:solidFill>
+                <a:latin typeface="Segoe UI"/>
               </a:defRPr>
             </a:pPr>
             <a:r>
-              <a:t>• The cents curve as a Gaussian process, two components: a damped cosine at the vibrato rate, plus a slow drift (a special case of the spectral mixture kernel, Wilson and Adams 2013).</a:t>
+              <a:t>•  The cents curve as a Gaussian process, two components: a damped cosine at the vibrato rate, plus a slow drift (a special case of the spectral mixture kernel, Wilson and Adams 2013).</a:t>
             </a:r>
           </a:p>
           <a:p>
             <a:pPr>
               <a:spcAft>
-                <a:spcPts val="800"/>
+                <a:spcPts val="1000"/>
               </a:spcAft>
-              <a:defRPr sz="2000">
+              <a:defRPr sz="2000" b="0">
                 <a:solidFill>
                   <a:srgbClr val="1A1A1A"/>
                 </a:solidFill>
+                <a:latin typeface="Segoe UI"/>
               </a:defRPr>
             </a:pPr>
             <a:r>
-              <a:t>• The prior states only where the curve's energy lives: a band at the rate, plus a drift band at zero.</a:t>
+              <a:t>•  The prior states only where the curve's energy lives: a band at the rate, plus a drift band at zero.</a:t>
             </a:r>
           </a:p>
           <a:p>
             <a:pPr>
               <a:spcAft>
-                <a:spcPts val="800"/>
+                <a:spcPts val="1000"/>
               </a:spcAft>
-              <a:defRPr sz="2000">
+              <a:defRPr sz="2000" b="0">
                 <a:solidFill>
                   <a:srgbClr val="1A1A1A"/>
                 </a:solidFill>
+                <a:latin typeface="Segoe UI"/>
               </a:defRPr>
             </a:pPr>
             <a:r>
-              <a:t>• Fit per note by exact marginal likelihood; variances from the evidence curvature.</a:t>
+              <a:t>•  Fit per note by exact marginal likelihood; variances from the evidence curvature.</a:t>
             </a:r>
           </a:p>
           <a:p>
             <a:pPr>
               <a:spcAft>
-                <a:spcPts val="800"/>
+                <a:spcPts val="1000"/>
               </a:spcAft>
-              <a:defRPr sz="2000">
+              <a:defRPr sz="2000" b="0">
                 <a:solidFill>
                   <a:srgbClr val="1A1A1A"/>
                 </a:solidFill>
+                <a:latin typeface="Segoe UI"/>
               </a:defRPr>
             </a:pPr>
             <a:r>
-              <a:t>• Channels from the posterior: c the realized average, γ from the vibrato component, f = μ₁.</a:t>
+              <a:t>•  Channels from the posterior: c the realized average, γ from the vibrato component, f = μ₁.</a:t>
             </a:r>
           </a:p>
         </p:txBody>
@@ -5728,8 +6244,8 @@
         </p:nvSpPr>
         <p:spPr>
           <a:xfrm>
-            <a:off x="411480" y="228600"/>
-            <a:ext cx="11338560" cy="685800"/>
+            <a:off x="11430000" y="6446520"/>
+            <a:ext cx="640080" cy="320040"/>
           </a:xfrm>
           <a:prstGeom prst="rect">
             <a:avLst/>
@@ -5743,21 +6259,102 @@
           <a:lstStyle/>
           <a:p>
             <a:pPr>
+              <a:defRPr sz="1200" b="0">
+                <a:solidFill>
+                  <a:srgbClr val="6B7280"/>
+                </a:solidFill>
+                <a:latin typeface="Segoe UI"/>
+              </a:defRPr>
+            </a:pPr>
+            <a:r>
+              <a:t>15</a:t>
+            </a:r>
+          </a:p>
+        </p:txBody>
+      </p:sp>
+      <p:sp>
+        <p:nvSpPr>
+          <p:cNvPr id="3" name="TextBox 2"/>
+          <p:cNvSpPr txBox="1"/>
+          <p:nvPr/>
+        </p:nvSpPr>
+        <p:spPr>
+          <a:xfrm>
+            <a:off x="411480" y="228600"/>
+            <a:ext cx="11338560" cy="685800"/>
+          </a:xfrm>
+          <a:prstGeom prst="rect">
+            <a:avLst/>
+          </a:prstGeom>
+          <a:noFill/>
+        </p:spPr>
+        <p:txBody>
+          <a:bodyPr wrap="none">
+            <a:spAutoFit/>
+          </a:bodyPr>
+          <a:lstStyle/>
+          <a:p>
+            <a:pPr>
               <a:defRPr sz="2800" b="1">
                 <a:solidFill>
                   <a:srgbClr val="1A1A1A"/>
                 </a:solidFill>
+                <a:latin typeface="Segoe UI"/>
               </a:defRPr>
             </a:pPr>
             <a:r>
               <a:t>One real note: the curve and its parts</a:t>
             </a:r>
+          </a:p>
+        </p:txBody>
+      </p:sp>
+      <p:sp>
+        <p:nvSpPr>
+          <p:cNvPr id="4" name="Rectangle 3"/>
+          <p:cNvSpPr/>
+          <p:nvPr/>
+        </p:nvSpPr>
+        <p:spPr>
+          <a:xfrm>
+            <a:off x="457200" y="896112"/>
+            <a:ext cx="11247120" cy="27940"/>
+          </a:xfrm>
+          <a:prstGeom prst="rect">
+            <a:avLst/>
+          </a:prstGeom>
+          <a:solidFill>
+            <a:srgbClr val="0072B2"/>
+          </a:solidFill>
+          <a:ln>
+            <a:noFill/>
+          </a:ln>
+          <a:effectLst/>
+        </p:spPr>
+        <p:style>
+          <a:lnRef idx="1">
+            <a:schemeClr val="accent1"/>
+          </a:lnRef>
+          <a:fillRef idx="3">
+            <a:schemeClr val="accent1"/>
+          </a:fillRef>
+          <a:effectRef idx="2">
+            <a:schemeClr val="accent1"/>
+          </a:effectRef>
+          <a:fontRef idx="minor">
+            <a:schemeClr val="lt1"/>
+          </a:fontRef>
+        </p:style>
+        <p:txBody>
+          <a:bodyPr rtlCol="0" anchor="ctr"/>
+          <a:lstStyle/>
+          <a:p>
+            <a:pPr algn="ctr"/>
           </a:p>
         </p:txBody>
       </p:sp>
       <p:pic>
         <p:nvPicPr>
-          <p:cNvPr id="3" name="Picture 2" descr="sm_estimator_explainer.png"/>
+          <p:cNvPr id="5" name="Picture 4" descr="sm_estimator_explainer.png"/>
           <p:cNvPicPr>
             <a:picLocks noChangeAspect="1"/>
           </p:cNvPicPr>
@@ -5781,7 +6378,7 @@
       </p:pic>
       <p:sp>
         <p:nvSpPr>
-          <p:cNvPr id="4" name="TextBox 3"/>
+          <p:cNvPr id="6" name="TextBox 5"/>
           <p:cNvSpPr txBox="1"/>
           <p:nvPr/>
         </p:nvSpPr>
@@ -5802,10 +6399,11 @@
           <a:lstStyle/>
           <a:p>
             <a:pPr>
-              <a:defRPr sz="1300">
+              <a:defRPr sz="1300" b="0">
                 <a:solidFill>
                   <a:srgbClr val="6B7280"/>
                 </a:solidFill>
+                <a:latin typeface="Segoe UI"/>
               </a:defRPr>
             </a:pPr>
             <a:r>
@@ -5840,8 +6438,8 @@
         </p:nvSpPr>
         <p:spPr>
           <a:xfrm>
-            <a:off x="411480" y="228600"/>
-            <a:ext cx="11338560" cy="685800"/>
+            <a:off x="11430000" y="6446520"/>
+            <a:ext cx="640080" cy="320040"/>
           </a:xfrm>
           <a:prstGeom prst="rect">
             <a:avLst/>
@@ -5855,14 +6453,15 @@
           <a:lstStyle/>
           <a:p>
             <a:pPr>
-              <a:defRPr sz="2800" b="1">
-                <a:solidFill>
-                  <a:srgbClr val="1A1A1A"/>
-                </a:solidFill>
+              <a:defRPr sz="1200" b="0">
+                <a:solidFill>
+                  <a:srgbClr val="6B7280"/>
+                </a:solidFill>
+                <a:latin typeface="Segoe UI"/>
               </a:defRPr>
             </a:pPr>
             <a:r>
-              <a:t>Phase 2: results (strings and winds, URMP)</a:t>
+              <a:t>16</a:t>
             </a:r>
           </a:p>
         </p:txBody>
@@ -5875,8 +6474,8 @@
         </p:nvSpPr>
         <p:spPr>
           <a:xfrm>
-            <a:off x="822960" y="1097280"/>
-            <a:ext cx="10515600" cy="640080"/>
+            <a:off x="411480" y="228600"/>
+            <a:ext cx="11338560" cy="685800"/>
           </a:xfrm>
           <a:prstGeom prst="rect">
             <a:avLst/>
@@ -5890,10 +6489,91 @@
           <a:lstStyle/>
           <a:p>
             <a:pPr>
-              <a:defRPr sz="2000">
+              <a:defRPr sz="2800" b="1">
+                <a:solidFill>
+                  <a:srgbClr val="1A1A1A"/>
+                </a:solidFill>
+                <a:latin typeface="Segoe UI"/>
+              </a:defRPr>
+            </a:pPr>
+            <a:r>
+              <a:t>Phase 2: results (strings and winds, URMP)</a:t>
+            </a:r>
+          </a:p>
+        </p:txBody>
+      </p:sp>
+      <p:sp>
+        <p:nvSpPr>
+          <p:cNvPr id="4" name="Rectangle 3"/>
+          <p:cNvSpPr/>
+          <p:nvPr/>
+        </p:nvSpPr>
+        <p:spPr>
+          <a:xfrm>
+            <a:off x="457200" y="896112"/>
+            <a:ext cx="11247120" cy="27940"/>
+          </a:xfrm>
+          <a:prstGeom prst="rect">
+            <a:avLst/>
+          </a:prstGeom>
+          <a:solidFill>
+            <a:srgbClr val="0072B2"/>
+          </a:solidFill>
+          <a:ln>
+            <a:noFill/>
+          </a:ln>
+          <a:effectLst/>
+        </p:spPr>
+        <p:style>
+          <a:lnRef idx="1">
+            <a:schemeClr val="accent1"/>
+          </a:lnRef>
+          <a:fillRef idx="3">
+            <a:schemeClr val="accent1"/>
+          </a:fillRef>
+          <a:effectRef idx="2">
+            <a:schemeClr val="accent1"/>
+          </a:effectRef>
+          <a:fontRef idx="minor">
+            <a:schemeClr val="lt1"/>
+          </a:fontRef>
+        </p:style>
+        <p:txBody>
+          <a:bodyPr rtlCol="0" anchor="ctr"/>
+          <a:lstStyle/>
+          <a:p>
+            <a:pPr algn="ctr"/>
+          </a:p>
+        </p:txBody>
+      </p:sp>
+      <p:sp>
+        <p:nvSpPr>
+          <p:cNvPr id="5" name="TextBox 4"/>
+          <p:cNvSpPr txBox="1"/>
+          <p:nvPr/>
+        </p:nvSpPr>
+        <p:spPr>
+          <a:xfrm>
+            <a:off x="822960" y="1097280"/>
+            <a:ext cx="10515600" cy="640080"/>
+          </a:xfrm>
+          <a:prstGeom prst="rect">
+            <a:avLst/>
+          </a:prstGeom>
+          <a:noFill/>
+        </p:spPr>
+        <p:txBody>
+          <a:bodyPr wrap="none">
+            <a:spAutoFit/>
+          </a:bodyPr>
+          <a:lstStyle/>
+          <a:p>
+            <a:pPr>
+              <a:defRPr sz="2000" b="0">
                 <a:solidFill>
                   <a:srgbClr val="0072B2"/>
                 </a:solidFill>
+                <a:latin typeface="Segoe UI"/>
               </a:defRPr>
             </a:pPr>
             <a:r>
@@ -5904,7 +6584,7 @@
       </p:sp>
       <p:sp>
         <p:nvSpPr>
-          <p:cNvPr id="4" name="TextBox 3"/>
+          <p:cNvPr id="6" name="TextBox 5"/>
           <p:cNvSpPr txBox="1"/>
           <p:nvPr/>
         </p:nvSpPr>
@@ -5926,76 +6606,81 @@
           <a:p>
             <a:pPr>
               <a:spcAft>
-                <a:spcPts val="800"/>
+                <a:spcPts val="1000"/>
               </a:spcAft>
-              <a:defRPr sz="2000">
+              <a:defRPr sz="2000" b="0">
                 <a:solidFill>
                   <a:srgbClr val="1A1A1A"/>
                 </a:solidFill>
+                <a:latin typeface="Segoe UI"/>
               </a:defRPr>
             </a:pPr>
             <a:r>
-              <a:t>• Preregistered, scored once on 13 held-out pieces. Δ = full model − no-graph ablation, paired per piece.</a:t>
+              <a:t>•  Preregistered, scored once on 13 held-out pieces. Δ = full model − no-graph ablation, paired per piece.</a:t>
             </a:r>
           </a:p>
           <a:p>
             <a:pPr>
               <a:spcAft>
-                <a:spcPts val="800"/>
+                <a:spcPts val="1000"/>
               </a:spcAft>
-              <a:defRPr sz="2000">
+              <a:defRPr sz="2000" b="0">
                 <a:solidFill>
                   <a:srgbClr val="1A1A1A"/>
                 </a:solidFill>
+                <a:latin typeface="Segoe UI"/>
               </a:defRPr>
             </a:pPr>
             <a:r>
-              <a:t>• Intonation recovery: ΔRMSE −0.877 cents, significant.</a:t>
+              <a:t>•  Intonation recovery: ΔRMSE −0.877 cents, significant.</a:t>
             </a:r>
           </a:p>
           <a:p>
             <a:pPr>
               <a:spcAft>
-                <a:spcPts val="800"/>
+                <a:spcPts val="1000"/>
               </a:spcAft>
-              <a:defRPr sz="2000">
+              <a:defRPr sz="2000" b="0">
                 <a:solidFill>
                   <a:srgbClr val="1A1A1A"/>
                 </a:solidFill>
+                <a:latin typeface="Segoe UI"/>
               </a:defRPr>
             </a:pPr>
             <a:r>
-              <a:t>• Vibrato calibration: ΔNLL −2.990 (extent), −0.564 (rate), both significant.</a:t>
+              <a:t>•  Vibrato calibration: ΔNLL −2.990 (extent), −0.564 (rate), both significant.</a:t>
             </a:r>
           </a:p>
           <a:p>
             <a:pPr>
               <a:spcAft>
-                <a:spcPts val="800"/>
+                <a:spcPts val="1000"/>
               </a:spcAft>
-              <a:defRPr sz="2000">
+              <a:defRPr sz="2000" b="0">
                 <a:solidFill>
                   <a:srgbClr val="1A1A1A"/>
                 </a:solidFill>
+                <a:latin typeface="Segoe UI"/>
               </a:defRPr>
             </a:pPr>
             <a:r>
-              <a:t>• Coverage 0.88–0.91 at nominal 0.90, all six channels.</a:t>
+              <a:t>•  Coverage 0.88–0.91 at nominal 0.90, all six channels.</a:t>
             </a:r>
           </a:p>
           <a:p>
             <a:pPr>
               <a:spcAft>
-                <a:spcPts val="800"/>
+                <a:spcPts val="1000"/>
               </a:spcAft>
-              <a:defRPr sz="2000">
+              <a:defRPr sz="2000" b="0">
                 <a:solidFill>
                   <a:srgbClr val="1A1A1A"/>
                 </a:solidFill>
+                <a:latin typeface="Segoe UI"/>
               </a:defRPr>
             </a:pPr>
             <a:r>
-              <a:t>• Timing calibration: no improvement (−0.030, interval includes zero). The loose end, taken up after Phase 3.</a:t>
+              <a:t>•  Timing calibration: no improvement (−0.030, interval includes zero). The loose end, taken up after Phase 3.</a:t>
             </a:r>
           </a:p>
         </p:txBody>
@@ -6026,8 +6711,8 @@
         </p:nvSpPr>
         <p:spPr>
           <a:xfrm>
-            <a:off x="411480" y="228600"/>
-            <a:ext cx="11338560" cy="685800"/>
+            <a:off x="11430000" y="6446520"/>
+            <a:ext cx="640080" cy="320040"/>
           </a:xfrm>
           <a:prstGeom prst="rect">
             <a:avLst/>
@@ -6041,14 +6726,15 @@
           <a:lstStyle/>
           <a:p>
             <a:pPr>
-              <a:defRPr sz="2800" b="1">
-                <a:solidFill>
-                  <a:srgbClr val="1A1A1A"/>
-                </a:solidFill>
+              <a:defRPr sz="1200" b="0">
+                <a:solidFill>
+                  <a:srgbClr val="6B7280"/>
+                </a:solidFill>
+                <a:latin typeface="Segoe UI"/>
               </a:defRPr>
             </a:pPr>
             <a:r>
-              <a:t>Phase 3: the waveform as the observation</a:t>
+              <a:t>17</a:t>
             </a:r>
           </a:p>
         </p:txBody>
@@ -6061,8 +6747,8 @@
         </p:nvSpPr>
         <p:spPr>
           <a:xfrm>
-            <a:off x="822960" y="1097280"/>
-            <a:ext cx="10515600" cy="640080"/>
+            <a:off x="411480" y="228600"/>
+            <a:ext cx="11338560" cy="685800"/>
           </a:xfrm>
           <a:prstGeom prst="rect">
             <a:avLst/>
@@ -6076,10 +6762,91 @@
           <a:lstStyle/>
           <a:p>
             <a:pPr>
-              <a:defRPr sz="2000">
+              <a:defRPr sz="2800" b="1">
+                <a:solidFill>
+                  <a:srgbClr val="1A1A1A"/>
+                </a:solidFill>
+                <a:latin typeface="Segoe UI"/>
+              </a:defRPr>
+            </a:pPr>
+            <a:r>
+              <a:t>Phase 3: the waveform as the observation</a:t>
+            </a:r>
+          </a:p>
+        </p:txBody>
+      </p:sp>
+      <p:sp>
+        <p:nvSpPr>
+          <p:cNvPr id="4" name="Rectangle 3"/>
+          <p:cNvSpPr/>
+          <p:nvPr/>
+        </p:nvSpPr>
+        <p:spPr>
+          <a:xfrm>
+            <a:off x="457200" y="896112"/>
+            <a:ext cx="11247120" cy="27940"/>
+          </a:xfrm>
+          <a:prstGeom prst="rect">
+            <a:avLst/>
+          </a:prstGeom>
+          <a:solidFill>
+            <a:srgbClr val="0072B2"/>
+          </a:solidFill>
+          <a:ln>
+            <a:noFill/>
+          </a:ln>
+          <a:effectLst/>
+        </p:spPr>
+        <p:style>
+          <a:lnRef idx="1">
+            <a:schemeClr val="accent1"/>
+          </a:lnRef>
+          <a:fillRef idx="3">
+            <a:schemeClr val="accent1"/>
+          </a:fillRef>
+          <a:effectRef idx="2">
+            <a:schemeClr val="accent1"/>
+          </a:effectRef>
+          <a:fontRef idx="minor">
+            <a:schemeClr val="lt1"/>
+          </a:fontRef>
+        </p:style>
+        <p:txBody>
+          <a:bodyPr rtlCol="0" anchor="ctr"/>
+          <a:lstStyle/>
+          <a:p>
+            <a:pPr algn="ctr"/>
+          </a:p>
+        </p:txBody>
+      </p:sp>
+      <p:sp>
+        <p:nvSpPr>
+          <p:cNvPr id="5" name="TextBox 4"/>
+          <p:cNvSpPr txBox="1"/>
+          <p:nvPr/>
+        </p:nvSpPr>
+        <p:spPr>
+          <a:xfrm>
+            <a:off x="822960" y="1097280"/>
+            <a:ext cx="10515600" cy="640080"/>
+          </a:xfrm>
+          <a:prstGeom prst="rect">
+            <a:avLst/>
+          </a:prstGeom>
+          <a:noFill/>
+        </p:spPr>
+        <p:txBody>
+          <a:bodyPr wrap="none">
+            <a:spAutoFit/>
+          </a:bodyPr>
+          <a:lstStyle/>
+          <a:p>
+            <a:pPr>
+              <a:defRPr sz="2000" b="0">
                 <a:solidFill>
                   <a:srgbClr val="0072B2"/>
                 </a:solidFill>
+                <a:latin typeface="Segoe UI"/>
               </a:defRPr>
             </a:pPr>
             <a:r>
@@ -6090,7 +6857,7 @@
       </p:sp>
       <p:sp>
         <p:nvSpPr>
-          <p:cNvPr id="4" name="TextBox 3"/>
+          <p:cNvPr id="6" name="TextBox 5"/>
           <p:cNvSpPr txBox="1"/>
           <p:nvPr/>
         </p:nvSpPr>
@@ -6112,31 +6879,33 @@
           <a:p>
             <a:pPr>
               <a:spcAft>
-                <a:spcPts val="800"/>
+                <a:spcPts val="1000"/>
               </a:spcAft>
-              <a:defRPr sz="2000">
+              <a:defRPr sz="2000" b="0">
                 <a:solidFill>
                   <a:srgbClr val="1A1A1A"/>
                 </a:solidFill>
+                <a:latin typeface="Segoe UI"/>
               </a:defRPr>
             </a:pPr>
             <a:r>
-              <a:t>• The likelihood block becomes the audio itself; the harmonic amplitudes are marginalized exactly (O(mp²), whole tracks exact).</a:t>
+              <a:t>•  The likelihood block becomes the audio itself; the harmonic amplitudes are marginalized exactly (O(mp²), whole tracks exact).</a:t>
             </a:r>
           </a:p>
           <a:p>
             <a:pPr>
               <a:spcAft>
-                <a:spcPts val="800"/>
+                <a:spcPts val="1000"/>
               </a:spcAft>
-              <a:defRPr sz="2000">
+              <a:defRPr sz="2000" b="0">
                 <a:solidFill>
                   <a:srgbClr val="1A1A1A"/>
                 </a:solidFill>
+                <a:latin typeface="Segoe UI"/>
               </a:defRPr>
             </a:pPr>
             <a:r>
-              <a:t>• Development studies: intonation at 2.29 cents median with no pitch tracker; beats the estimator chain on winds.</a:t>
+              <a:t>•  Development studies: intonation at 2.29 cents median with no pitch tracker; beats the estimator chain on winds.</a:t>
             </a:r>
           </a:p>
         </p:txBody>
@@ -6167,8 +6936,8 @@
         </p:nvSpPr>
         <p:spPr>
           <a:xfrm>
-            <a:off x="411480" y="228600"/>
-            <a:ext cx="11338560" cy="685800"/>
+            <a:off x="11430000" y="6446520"/>
+            <a:ext cx="640080" cy="320040"/>
           </a:xfrm>
           <a:prstGeom prst="rect">
             <a:avLst/>
@@ -6182,21 +6951,102 @@
           <a:lstStyle/>
           <a:p>
             <a:pPr>
+              <a:defRPr sz="1200" b="0">
+                <a:solidFill>
+                  <a:srgbClr val="6B7280"/>
+                </a:solidFill>
+                <a:latin typeface="Segoe UI"/>
+              </a:defRPr>
+            </a:pPr>
+            <a:r>
+              <a:t>18</a:t>
+            </a:r>
+          </a:p>
+        </p:txBody>
+      </p:sp>
+      <p:sp>
+        <p:nvSpPr>
+          <p:cNvPr id="3" name="TextBox 2"/>
+          <p:cNvSpPr txBox="1"/>
+          <p:nvPr/>
+        </p:nvSpPr>
+        <p:spPr>
+          <a:xfrm>
+            <a:off x="411480" y="228600"/>
+            <a:ext cx="11338560" cy="685800"/>
+          </a:xfrm>
+          <a:prstGeom prst="rect">
+            <a:avLst/>
+          </a:prstGeom>
+          <a:noFill/>
+        </p:spPr>
+        <p:txBody>
+          <a:bodyPr wrap="none">
+            <a:spAutoFit/>
+          </a:bodyPr>
+          <a:lstStyle/>
+          <a:p>
+            <a:pPr>
               <a:defRPr sz="2800" b="1">
                 <a:solidFill>
                   <a:srgbClr val="1A1A1A"/>
                 </a:solidFill>
+                <a:latin typeface="Segoe UI"/>
               </a:defRPr>
             </a:pPr>
             <a:r>
               <a:t>Running now: the curve straight from the waveform</a:t>
             </a:r>
+          </a:p>
+        </p:txBody>
+      </p:sp>
+      <p:sp>
+        <p:nvSpPr>
+          <p:cNvPr id="4" name="Rectangle 3"/>
+          <p:cNvSpPr/>
+          <p:nvPr/>
+        </p:nvSpPr>
+        <p:spPr>
+          <a:xfrm>
+            <a:off x="457200" y="896112"/>
+            <a:ext cx="11247120" cy="27940"/>
+          </a:xfrm>
+          <a:prstGeom prst="rect">
+            <a:avLst/>
+          </a:prstGeom>
+          <a:solidFill>
+            <a:srgbClr val="0072B2"/>
+          </a:solidFill>
+          <a:ln>
+            <a:noFill/>
+          </a:ln>
+          <a:effectLst/>
+        </p:spPr>
+        <p:style>
+          <a:lnRef idx="1">
+            <a:schemeClr val="accent1"/>
+          </a:lnRef>
+          <a:fillRef idx="3">
+            <a:schemeClr val="accent1"/>
+          </a:fillRef>
+          <a:effectRef idx="2">
+            <a:schemeClr val="accent1"/>
+          </a:effectRef>
+          <a:fontRef idx="minor">
+            <a:schemeClr val="lt1"/>
+          </a:fontRef>
+        </p:style>
+        <p:txBody>
+          <a:bodyPr rtlCol="0" anchor="ctr"/>
+          <a:lstStyle/>
+          <a:p>
+            <a:pPr algn="ctr"/>
           </a:p>
         </p:txBody>
       </p:sp>
       <p:pic>
         <p:nvPicPr>
-          <p:cNvPr id="3" name="Picture 2" descr="phase3_curve_proto.png"/>
+          <p:cNvPr id="5" name="Picture 4" descr="phase3_curve_proto.png"/>
           <p:cNvPicPr>
             <a:picLocks noChangeAspect="1"/>
           </p:cNvPicPr>
@@ -6220,7 +7070,7 @@
       </p:pic>
       <p:sp>
         <p:nvSpPr>
-          <p:cNvPr id="4" name="TextBox 3"/>
+          <p:cNvPr id="6" name="TextBox 5"/>
           <p:cNvSpPr txBox="1"/>
           <p:nvPr/>
         </p:nvSpPr>
@@ -6241,10 +7091,11 @@
           <a:lstStyle/>
           <a:p>
             <a:pPr>
-              <a:defRPr sz="1300">
+              <a:defRPr sz="1300" b="0">
                 <a:solidFill>
                   <a:srgbClr val="6B7280"/>
                 </a:solidFill>
+                <a:latin typeface="Segoe UI"/>
               </a:defRPr>
             </a:pPr>
             <a:r>
@@ -6279,8 +7130,8 @@
         </p:nvSpPr>
         <p:spPr>
           <a:xfrm>
-            <a:off x="411480" y="228600"/>
-            <a:ext cx="11338560" cy="685800"/>
+            <a:off x="11430000" y="6446520"/>
+            <a:ext cx="640080" cy="320040"/>
           </a:xfrm>
           <a:prstGeom prst="rect">
             <a:avLst/>
@@ -6294,14 +7145,15 @@
           <a:lstStyle/>
           <a:p>
             <a:pPr>
-              <a:defRPr sz="2800" b="1">
-                <a:solidFill>
-                  <a:srgbClr val="1A1A1A"/>
-                </a:solidFill>
+              <a:defRPr sz="1200" b="0">
+                <a:solidFill>
+                  <a:srgbClr val="6B7280"/>
+                </a:solidFill>
+                <a:latin typeface="Segoe UI"/>
               </a:defRPr>
             </a:pPr>
             <a:r>
-              <a:t>Timing noise is correlated across notes</a:t>
+              <a:t>19</a:t>
             </a:r>
           </a:p>
         </p:txBody>
@@ -6314,8 +7166,8 @@
         </p:nvSpPr>
         <p:spPr>
           <a:xfrm>
-            <a:off x="822960" y="1097280"/>
-            <a:ext cx="10515600" cy="640080"/>
+            <a:off x="411480" y="228600"/>
+            <a:ext cx="11338560" cy="685800"/>
           </a:xfrm>
           <a:prstGeom prst="rect">
             <a:avLst/>
@@ -6329,10 +7181,91 @@
           <a:lstStyle/>
           <a:p>
             <a:pPr>
-              <a:defRPr sz="2000">
+              <a:defRPr sz="2800" b="1">
+                <a:solidFill>
+                  <a:srgbClr val="1A1A1A"/>
+                </a:solidFill>
+                <a:latin typeface="Segoe UI"/>
+              </a:defRPr>
+            </a:pPr>
+            <a:r>
+              <a:t>Timing noise is correlated across notes</a:t>
+            </a:r>
+          </a:p>
+        </p:txBody>
+      </p:sp>
+      <p:sp>
+        <p:nvSpPr>
+          <p:cNvPr id="4" name="Rectangle 3"/>
+          <p:cNvSpPr/>
+          <p:nvPr/>
+        </p:nvSpPr>
+        <p:spPr>
+          <a:xfrm>
+            <a:off x="457200" y="896112"/>
+            <a:ext cx="11247120" cy="27940"/>
+          </a:xfrm>
+          <a:prstGeom prst="rect">
+            <a:avLst/>
+          </a:prstGeom>
+          <a:solidFill>
+            <a:srgbClr val="0072B2"/>
+          </a:solidFill>
+          <a:ln>
+            <a:noFill/>
+          </a:ln>
+          <a:effectLst/>
+        </p:spPr>
+        <p:style>
+          <a:lnRef idx="1">
+            <a:schemeClr val="accent1"/>
+          </a:lnRef>
+          <a:fillRef idx="3">
+            <a:schemeClr val="accent1"/>
+          </a:fillRef>
+          <a:effectRef idx="2">
+            <a:schemeClr val="accent1"/>
+          </a:effectRef>
+          <a:fontRef idx="minor">
+            <a:schemeClr val="lt1"/>
+          </a:fontRef>
+        </p:style>
+        <p:txBody>
+          <a:bodyPr rtlCol="0" anchor="ctr"/>
+          <a:lstStyle/>
+          <a:p>
+            <a:pPr algn="ctr"/>
+          </a:p>
+        </p:txBody>
+      </p:sp>
+      <p:sp>
+        <p:nvSpPr>
+          <p:cNvPr id="5" name="TextBox 4"/>
+          <p:cNvSpPr txBox="1"/>
+          <p:nvPr/>
+        </p:nvSpPr>
+        <p:spPr>
+          <a:xfrm>
+            <a:off x="822960" y="1097280"/>
+            <a:ext cx="10515600" cy="640080"/>
+          </a:xfrm>
+          <a:prstGeom prst="rect">
+            <a:avLst/>
+          </a:prstGeom>
+          <a:noFill/>
+        </p:spPr>
+        <p:txBody>
+          <a:bodyPr wrap="none">
+            <a:spAutoFit/>
+          </a:bodyPr>
+          <a:lstStyle/>
+          <a:p>
+            <a:pPr>
+              <a:defRPr sz="2000" b="0">
                 <a:solidFill>
                   <a:srgbClr val="0072B2"/>
                 </a:solidFill>
+                <a:latin typeface="Segoe UI"/>
               </a:defRPr>
             </a:pPr>
             <a:r>
@@ -6343,7 +7276,7 @@
       </p:sp>
       <p:sp>
         <p:nvSpPr>
-          <p:cNvPr id="4" name="TextBox 3"/>
+          <p:cNvPr id="6" name="TextBox 5"/>
           <p:cNvSpPr txBox="1"/>
           <p:nvPr/>
         </p:nvSpPr>
@@ -6365,61 +7298,65 @@
           <a:p>
             <a:pPr>
               <a:spcAft>
-                <a:spcPts val="800"/>
+                <a:spcPts val="1000"/>
               </a:spcAft>
-              <a:defRPr sz="2000">
+              <a:defRPr sz="2000" b="0">
                 <a:solidFill>
                   <a:srgbClr val="1A1A1A"/>
                 </a:solidFill>
+                <a:latin typeface="Segoe UI"/>
               </a:defRPr>
             </a:pPr>
             <a:r>
-              <a:t>• Why timing did not calibrate: alignment error is correlated along score time; a diagonal noise row cannot represent it.</a:t>
+              <a:t>•  Why timing did not calibrate: alignment error is correlated along score time; a diagonal noise row cannot represent it.</a:t>
             </a:r>
           </a:p>
           <a:p>
             <a:pPr>
               <a:spcAft>
-                <a:spcPts val="800"/>
+                <a:spcPts val="1000"/>
               </a:spcAft>
-              <a:defRPr sz="2000">
+              <a:defRPr sz="2000" b="0">
                 <a:solidFill>
                   <a:srgbClr val="1A1A1A"/>
                 </a:solidFill>
+                <a:latin typeface="Segoe UI"/>
               </a:defRPr>
             </a:pPr>
             <a:r>
-              <a:t>• The evidence detects the correlation on 97–100% of pieces (median ρ 0.45–0.60).</a:t>
+              <a:t>•  The evidence detects the correlation on 97–100% of pieces (median ρ 0.45–0.60).</a:t>
             </a:r>
           </a:p>
           <a:p>
             <a:pPr>
               <a:spcAft>
-                <a:spcPts val="800"/>
+                <a:spcPts val="1000"/>
               </a:spcAft>
-              <a:defRPr sz="2000">
+              <a:defRPr sz="2000" b="0">
                 <a:solidFill>
                   <a:srgbClr val="1A1A1A"/>
                 </a:solidFill>
+                <a:latin typeface="Segoe UI"/>
               </a:defRPr>
             </a:pPr>
             <a:r>
-              <a:t>• Calibration improves (ΔNLL −0.111, significant); timing error falls ~20% (99 → 80 ms).</a:t>
+              <a:t>•  Calibration improves (ΔNLL −0.111, significant); timing error falls ~20% (99 → 80 ms).</a:t>
             </a:r>
           </a:p>
           <a:p>
             <a:pPr>
               <a:spcAft>
-                <a:spcPts val="800"/>
+                <a:spcPts val="1000"/>
               </a:spcAft>
-              <a:defRPr sz="2000">
+              <a:defRPr sz="2000" b="0">
                 <a:solidFill>
                   <a:srgbClr val="1A1A1A"/>
                 </a:solidFill>
+                <a:latin typeface="Segoe UI"/>
               </a:defRPr>
             </a:pPr>
             <a:r>
-              <a:t>• Reproduced three ways: original masks, fresh masks, joint refit.</a:t>
+              <a:t>•  Reproduced three ways: original masks, fresh masks, joint refit.</a:t>
             </a:r>
           </a:p>
         </p:txBody>
@@ -6450,8 +7387,8 @@
         </p:nvSpPr>
         <p:spPr>
           <a:xfrm>
-            <a:off x="411480" y="228600"/>
-            <a:ext cx="11338560" cy="685800"/>
+            <a:off x="11430000" y="6446520"/>
+            <a:ext cx="640080" cy="320040"/>
           </a:xfrm>
           <a:prstGeom prst="rect">
             <a:avLst/>
@@ -6465,14 +7402,15 @@
           <a:lstStyle/>
           <a:p>
             <a:pPr>
-              <a:defRPr sz="2800" b="1">
-                <a:solidFill>
-                  <a:srgbClr val="1A1A1A"/>
-                </a:solidFill>
+              <a:defRPr sz="1200" b="0">
+                <a:solidFill>
+                  <a:srgbClr val="6B7280"/>
+                </a:solidFill>
+                <a:latin typeface="Segoe UI"/>
               </a:defRPr>
             </a:pPr>
             <a:r>
-              <a:t>Expressive performance</a:t>
+              <a:t>2</a:t>
             </a:r>
           </a:p>
         </p:txBody>
@@ -6485,6 +7423,86 @@
         </p:nvSpPr>
         <p:spPr>
           <a:xfrm>
+            <a:off x="411480" y="228600"/>
+            <a:ext cx="11338560" cy="685800"/>
+          </a:xfrm>
+          <a:prstGeom prst="rect">
+            <a:avLst/>
+          </a:prstGeom>
+          <a:noFill/>
+        </p:spPr>
+        <p:txBody>
+          <a:bodyPr wrap="none">
+            <a:spAutoFit/>
+          </a:bodyPr>
+          <a:lstStyle/>
+          <a:p>
+            <a:pPr>
+              <a:defRPr sz="2800" b="1">
+                <a:solidFill>
+                  <a:srgbClr val="1A1A1A"/>
+                </a:solidFill>
+                <a:latin typeface="Segoe UI"/>
+              </a:defRPr>
+            </a:pPr>
+            <a:r>
+              <a:t>Expressive performance</a:t>
+            </a:r>
+          </a:p>
+        </p:txBody>
+      </p:sp>
+      <p:sp>
+        <p:nvSpPr>
+          <p:cNvPr id="4" name="Rectangle 3"/>
+          <p:cNvSpPr/>
+          <p:nvPr/>
+        </p:nvSpPr>
+        <p:spPr>
+          <a:xfrm>
+            <a:off x="457200" y="896112"/>
+            <a:ext cx="11247120" cy="27940"/>
+          </a:xfrm>
+          <a:prstGeom prst="rect">
+            <a:avLst/>
+          </a:prstGeom>
+          <a:solidFill>
+            <a:srgbClr val="0072B2"/>
+          </a:solidFill>
+          <a:ln>
+            <a:noFill/>
+          </a:ln>
+          <a:effectLst/>
+        </p:spPr>
+        <p:style>
+          <a:lnRef idx="1">
+            <a:schemeClr val="accent1"/>
+          </a:lnRef>
+          <a:fillRef idx="3">
+            <a:schemeClr val="accent1"/>
+          </a:fillRef>
+          <a:effectRef idx="2">
+            <a:schemeClr val="accent1"/>
+          </a:effectRef>
+          <a:fontRef idx="minor">
+            <a:schemeClr val="lt1"/>
+          </a:fontRef>
+        </p:style>
+        <p:txBody>
+          <a:bodyPr rtlCol="0" anchor="ctr"/>
+          <a:lstStyle/>
+          <a:p>
+            <a:pPr algn="ctr"/>
+          </a:p>
+        </p:txBody>
+      </p:sp>
+      <p:sp>
+        <p:nvSpPr>
+          <p:cNvPr id="5" name="TextBox 4"/>
+          <p:cNvSpPr txBox="1"/>
+          <p:nvPr/>
+        </p:nvSpPr>
+        <p:spPr>
+          <a:xfrm>
             <a:off x="822960" y="1097280"/>
             <a:ext cx="10607040" cy="4389120"/>
           </a:xfrm>
@@ -6501,23 +7519,24 @@
           <a:p>
             <a:pPr>
               <a:spcAft>
-                <a:spcPts val="800"/>
+                <a:spcPts val="1000"/>
               </a:spcAft>
-              <a:defRPr sz="2000">
+              <a:defRPr sz="2000" b="0">
                 <a:solidFill>
                   <a:srgbClr val="1A1A1A"/>
                 </a:solidFill>
+                <a:latin typeface="Segoe UI"/>
               </a:defRPr>
             </a:pPr>
             <a:r>
-              <a:t>• The score fixes pitches and note values. Performers add the rest: when, how long, how loud, and how the pitch moves inside the note. These deviations are the expression.</a:t>
+              <a:t>•  The score fixes pitches and note values. Performers add the rest: when, how long, how loud, and how the pitch moves inside the note. These deviations are the expression.</a:t>
             </a:r>
           </a:p>
         </p:txBody>
       </p:sp>
       <p:pic>
         <p:nvPicPr>
-          <p:cNvPr id="4" name="Picture 3" descr="deck_concept.png"/>
+          <p:cNvPr id="6" name="Picture 5" descr="deck_concept.png"/>
           <p:cNvPicPr>
             <a:picLocks noChangeAspect="1"/>
           </p:cNvPicPr>
@@ -6541,7 +7560,7 @@
       </p:pic>
       <p:sp>
         <p:nvSpPr>
-          <p:cNvPr id="5" name="TextBox 4"/>
+          <p:cNvPr id="7" name="TextBox 6"/>
           <p:cNvSpPr txBox="1"/>
           <p:nvPr/>
         </p:nvSpPr>
@@ -6562,10 +7581,11 @@
           <a:lstStyle/>
           <a:p>
             <a:pPr>
-              <a:defRPr sz="1300">
+              <a:defRPr sz="1300" b="0">
                 <a:solidFill>
                   <a:srgbClr val="6B7280"/>
                 </a:solidFill>
+                <a:latin typeface="Segoe UI"/>
               </a:defRPr>
             </a:pPr>
             <a:r>
@@ -6576,7 +7596,7 @@
       </p:sp>
       <p:pic>
         <p:nvPicPr>
-          <p:cNvPr id="6" name="flat.wav">
+          <p:cNvPr id="8" name="flat.wav">
             <a:hlinkClick r:id="" action="ppaction://media"/>
           </p:cNvPr>
           <p:cNvPicPr>
@@ -6609,7 +7629,7 @@
       </p:pic>
       <p:pic>
         <p:nvPicPr>
-          <p:cNvPr id="7" name="expressive.wav">
+          <p:cNvPr id="9" name="expressive.wav">
             <a:hlinkClick r:id="" action="ppaction://media"/>
           </p:cNvPr>
           <p:cNvPicPr>
@@ -6658,7 +7678,7 @@
                   </p:stCondLst>
                 </p:cTn>
                 <p:tgtEl>
-                  <p:spTgt spid="6"/>
+                  <p:spTgt spid="8"/>
                 </p:tgtEl>
               </p:cMediaNode>
             </p:video>
@@ -6670,7 +7690,7 @@
                   </p:stCondLst>
                 </p:cTn>
                 <p:tgtEl>
-                  <p:spTgt spid="7"/>
+                  <p:spTgt spid="9"/>
                 </p:tgtEl>
               </p:cMediaNode>
             </p:video>
@@ -6700,8 +7720,8 @@
         </p:nvSpPr>
         <p:spPr>
           <a:xfrm>
-            <a:off x="411480" y="228600"/>
-            <a:ext cx="11338560" cy="685800"/>
+            <a:off x="11430000" y="6446520"/>
+            <a:ext cx="640080" cy="320040"/>
           </a:xfrm>
           <a:prstGeom prst="rect">
             <a:avLst/>
@@ -6715,21 +7735,102 @@
           <a:lstStyle/>
           <a:p>
             <a:pPr>
+              <a:defRPr sz="1200" b="0">
+                <a:solidFill>
+                  <a:srgbClr val="6B7280"/>
+                </a:solidFill>
+                <a:latin typeface="Segoe UI"/>
+              </a:defRPr>
+            </a:pPr>
+            <a:r>
+              <a:t>20</a:t>
+            </a:r>
+          </a:p>
+        </p:txBody>
+      </p:sp>
+      <p:sp>
+        <p:nvSpPr>
+          <p:cNvPr id="3" name="TextBox 2"/>
+          <p:cNvSpPr txBox="1"/>
+          <p:nvPr/>
+        </p:nvSpPr>
+        <p:spPr>
+          <a:xfrm>
+            <a:off x="411480" y="228600"/>
+            <a:ext cx="11338560" cy="685800"/>
+          </a:xfrm>
+          <a:prstGeom prst="rect">
+            <a:avLst/>
+          </a:prstGeom>
+          <a:noFill/>
+        </p:spPr>
+        <p:txBody>
+          <a:bodyPr wrap="none">
+            <a:spAutoFit/>
+          </a:bodyPr>
+          <a:lstStyle/>
+          <a:p>
+            <a:pPr>
               <a:defRPr sz="2800" b="1">
                 <a:solidFill>
                   <a:srgbClr val="1A1A1A"/>
                 </a:solidFill>
+                <a:latin typeface="Segoe UI"/>
               </a:defRPr>
             </a:pPr>
             <a:r>
               <a:t>Held-out timing, with and without the correlation</a:t>
             </a:r>
+          </a:p>
+        </p:txBody>
+      </p:sp>
+      <p:sp>
+        <p:nvSpPr>
+          <p:cNvPr id="4" name="Rectangle 3"/>
+          <p:cNvSpPr/>
+          <p:nvPr/>
+        </p:nvSpPr>
+        <p:spPr>
+          <a:xfrm>
+            <a:off x="457200" y="896112"/>
+            <a:ext cx="11247120" cy="27940"/>
+          </a:xfrm>
+          <a:prstGeom prst="rect">
+            <a:avLst/>
+          </a:prstGeom>
+          <a:solidFill>
+            <a:srgbClr val="0072B2"/>
+          </a:solidFill>
+          <a:ln>
+            <a:noFill/>
+          </a:ln>
+          <a:effectLst/>
+        </p:spPr>
+        <p:style>
+          <a:lnRef idx="1">
+            <a:schemeClr val="accent1"/>
+          </a:lnRef>
+          <a:fillRef idx="3">
+            <a:schemeClr val="accent1"/>
+          </a:fillRef>
+          <a:effectRef idx="2">
+            <a:schemeClr val="accent1"/>
+          </a:effectRef>
+          <a:fontRef idx="minor">
+            <a:schemeClr val="lt1"/>
+          </a:fontRef>
+        </p:style>
+        <p:txBody>
+          <a:bodyPr rtlCol="0" anchor="ctr"/>
+          <a:lstStyle/>
+          <a:p>
+            <a:pPr algn="ctr"/>
           </a:p>
         </p:txBody>
       </p:sp>
       <p:pic>
         <p:nvPicPr>
-          <p:cNvPr id="3" name="Picture 2" descr="corrnoise_tau_dev.png"/>
+          <p:cNvPr id="5" name="Picture 4" descr="corrnoise_tau_dev.png"/>
           <p:cNvPicPr>
             <a:picLocks noChangeAspect="1"/>
           </p:cNvPicPr>
@@ -6753,7 +7854,7 @@
       </p:pic>
       <p:sp>
         <p:nvSpPr>
-          <p:cNvPr id="4" name="TextBox 3"/>
+          <p:cNvPr id="6" name="TextBox 5"/>
           <p:cNvSpPr txBox="1"/>
           <p:nvPr/>
         </p:nvSpPr>
@@ -6774,10 +7875,11 @@
           <a:lstStyle/>
           <a:p>
             <a:pPr>
-              <a:defRPr sz="1300">
+              <a:defRPr sz="1300" b="0">
                 <a:solidFill>
                   <a:srgbClr val="6B7280"/>
                 </a:solidFill>
+                <a:latin typeface="Segoe UI"/>
               </a:defRPr>
             </a:pPr>
             <a:r>
@@ -6812,8 +7914,8 @@
         </p:nvSpPr>
         <p:spPr>
           <a:xfrm>
-            <a:off x="411480" y="228600"/>
-            <a:ext cx="11338560" cy="685800"/>
+            <a:off x="11430000" y="6446520"/>
+            <a:ext cx="640080" cy="320040"/>
           </a:xfrm>
           <a:prstGeom prst="rect">
             <a:avLst/>
@@ -6827,21 +7929,102 @@
           <a:lstStyle/>
           <a:p>
             <a:pPr>
+              <a:defRPr sz="1200" b="0">
+                <a:solidFill>
+                  <a:srgbClr val="6B7280"/>
+                </a:solidFill>
+                <a:latin typeface="Segoe UI"/>
+              </a:defRPr>
+            </a:pPr>
+            <a:r>
+              <a:t>21</a:t>
+            </a:r>
+          </a:p>
+        </p:txBody>
+      </p:sp>
+      <p:sp>
+        <p:nvSpPr>
+          <p:cNvPr id="3" name="TextBox 2"/>
+          <p:cNvSpPr txBox="1"/>
+          <p:nvPr/>
+        </p:nvSpPr>
+        <p:spPr>
+          <a:xfrm>
+            <a:off x="411480" y="228600"/>
+            <a:ext cx="11338560" cy="685800"/>
+          </a:xfrm>
+          <a:prstGeom prst="rect">
+            <a:avLst/>
+          </a:prstGeom>
+          <a:noFill/>
+        </p:spPr>
+        <p:txBody>
+          <a:bodyPr wrap="none">
+            <a:spAutoFit/>
+          </a:bodyPr>
+          <a:lstStyle/>
+          <a:p>
+            <a:pPr>
               <a:defRPr sz="2800" b="1">
                 <a:solidFill>
                   <a:srgbClr val="1A1A1A"/>
                 </a:solidFill>
+                <a:latin typeface="Segoe UI"/>
               </a:defRPr>
             </a:pPr>
             <a:r>
               <a:t>From here (proposed sequencing)</a:t>
             </a:r>
+          </a:p>
+        </p:txBody>
+      </p:sp>
+      <p:sp>
+        <p:nvSpPr>
+          <p:cNvPr id="4" name="Rectangle 3"/>
+          <p:cNvSpPr/>
+          <p:nvPr/>
+        </p:nvSpPr>
+        <p:spPr>
+          <a:xfrm>
+            <a:off x="457200" y="896112"/>
+            <a:ext cx="11247120" cy="27940"/>
+          </a:xfrm>
+          <a:prstGeom prst="rect">
+            <a:avLst/>
+          </a:prstGeom>
+          <a:solidFill>
+            <a:srgbClr val="0072B2"/>
+          </a:solidFill>
+          <a:ln>
+            <a:noFill/>
+          </a:ln>
+          <a:effectLst/>
+        </p:spPr>
+        <p:style>
+          <a:lnRef idx="1">
+            <a:schemeClr val="accent1"/>
+          </a:lnRef>
+          <a:fillRef idx="3">
+            <a:schemeClr val="accent1"/>
+          </a:fillRef>
+          <a:effectRef idx="2">
+            <a:schemeClr val="accent1"/>
+          </a:effectRef>
+          <a:fontRef idx="minor">
+            <a:schemeClr val="lt1"/>
+          </a:fontRef>
+        </p:style>
+        <p:txBody>
+          <a:bodyPr rtlCol="0" anchor="ctr"/>
+          <a:lstStyle/>
+          <a:p>
+            <a:pPr algn="ctr"/>
           </a:p>
         </p:txBody>
       </p:sp>
       <p:graphicFrame>
         <p:nvGraphicFramePr>
-          <p:cNvPr id="3" name="Table 2"/>
+          <p:cNvPr id="5" name="Table 4"/>
           <p:cNvGraphicFramePr>
             <a:graphicFrameLocks noGrp="1"/>
           </p:cNvGraphicFramePr>
@@ -6868,14 +8051,23 @@
                     <a:lstStyle/>
                     <a:p>
                       <a:pPr>
-                        <a:defRPr sz="1800"/>
+                        <a:defRPr sz="1800" b="1">
+                          <a:solidFill>
+                            <a:srgbClr val="0072B2"/>
+                          </a:solidFill>
+                          <a:latin typeface="Segoe UI"/>
+                        </a:defRPr>
                       </a:pPr>
                       <a:r>
                         <a:t>now</a:t>
                       </a:r>
                     </a:p>
                   </a:txBody>
-                  <a:tcPr/>
+                  <a:tcPr>
+                    <a:solidFill>
+                      <a:srgbClr val="FFFFFF"/>
+                    </a:solidFill>
+                  </a:tcPr>
                 </a:tc>
                 <a:tc>
                   <a:txBody>
@@ -6883,14 +8075,23 @@
                     <a:lstStyle/>
                     <a:p>
                       <a:pPr>
-                        <a:defRPr sz="1800"/>
+                        <a:defRPr sz="1800" b="0">
+                          <a:solidFill>
+                            <a:srgbClr val="1A1A1A"/>
+                          </a:solidFill>
+                          <a:latin typeface="Segoe UI"/>
+                        </a:defRPr>
                       </a:pPr>
                       <a:r>
                         <a:t>integrate the full-corpus learned-spectrum run (done this week)</a:t>
                       </a:r>
                     </a:p>
                   </a:txBody>
-                  <a:tcPr/>
+                  <a:tcPr>
+                    <a:solidFill>
+                      <a:srgbClr val="FFFFFF"/>
+                    </a:solidFill>
+                  </a:tcPr>
                 </a:tc>
               </a:tr>
               <a:tr h="960120">
@@ -6900,14 +8101,23 @@
                     <a:lstStyle/>
                     <a:p>
                       <a:pPr>
-                        <a:defRPr sz="1800"/>
+                        <a:defRPr sz="1800" b="1">
+                          <a:solidFill>
+                            <a:srgbClr val="0072B2"/>
+                          </a:solidFill>
+                          <a:latin typeface="Segoe UI"/>
+                        </a:defRPr>
                       </a:pPr>
                       <a:r>
                         <a:t>next 2 weeks</a:t>
                       </a:r>
                     </a:p>
                   </a:txBody>
-                  <a:tcPr/>
+                  <a:tcPr>
+                    <a:solidFill>
+                      <a:srgbClr val="E5E7EB"/>
+                    </a:solidFill>
+                  </a:tcPr>
                 </a:tc>
                 <a:tc>
                   <a:txBody>
@@ -6915,14 +8125,23 @@
                     <a:lstStyle/>
                     <a:p>
                       <a:pPr>
-                        <a:defRPr sz="1800"/>
+                        <a:defRPr sz="1800" b="0">
+                          <a:solidFill>
+                            <a:srgbClr val="1A1A1A"/>
+                          </a:solidFill>
+                          <a:latin typeface="Segoe UI"/>
+                        </a:defRPr>
                       </a:pPr>
                       <a:r>
                         <a:t>freeze the timing-noise registration once the pool is decided; batch-evaluate the curve-from-waveform prototype</a:t>
                       </a:r>
                     </a:p>
                   </a:txBody>
-                  <a:tcPr/>
+                  <a:tcPr>
+                    <a:solidFill>
+                      <a:srgbClr val="E5E7EB"/>
+                    </a:solidFill>
+                  </a:tcPr>
                 </a:tc>
               </a:tr>
               <a:tr h="960120">
@@ -6932,14 +8151,23 @@
                     <a:lstStyle/>
                     <a:p>
                       <a:pPr>
-                        <a:defRPr sz="1800"/>
+                        <a:defRPr sz="1800" b="1">
+                          <a:solidFill>
+                            <a:srgbClr val="0072B2"/>
+                          </a:solidFill>
+                          <a:latin typeface="Segoe UI"/>
+                        </a:defRPr>
                       </a:pPr>
                       <a:r>
                         <a:t>November</a:t>
                       </a:r>
                     </a:p>
                   </a:txBody>
-                  <a:tcPr/>
+                  <a:tcPr>
+                    <a:solidFill>
+                      <a:srgbClr val="FFFFFF"/>
+                    </a:solidFill>
+                  </a:tcPr>
                 </a:tc>
                 <a:tc>
                   <a:txBody>
@@ -6947,14 +8175,23 @@
                     <a:lstStyle/>
                     <a:p>
                       <a:pPr>
-                        <a:defRPr sz="1800"/>
+                        <a:defRPr sz="1800" b="0">
+                          <a:solidFill>
+                            <a:srgbClr val="1A1A1A"/>
+                          </a:solidFill>
+                          <a:latin typeface="Segoe UI"/>
+                        </a:defRPr>
                       </a:pPr>
                       <a:r>
                         <a:t>decide the channel design (scalars vs curve level); run the timing confirmation, one shot</a:t>
                       </a:r>
                     </a:p>
                   </a:txBody>
-                  <a:tcPr/>
+                  <a:tcPr>
+                    <a:solidFill>
+                      <a:srgbClr val="FFFFFF"/>
+                    </a:solidFill>
+                  </a:tcPr>
                 </a:tc>
               </a:tr>
               <a:tr h="960120">
@@ -6964,14 +8201,23 @@
                     <a:lstStyle/>
                     <a:p>
                       <a:pPr>
-                        <a:defRPr sz="1800"/>
+                        <a:defRPr sz="1800" b="1">
+                          <a:solidFill>
+                            <a:srgbClr val="0072B2"/>
+                          </a:solidFill>
+                          <a:latin typeface="Segoe UI"/>
+                        </a:defRPr>
                       </a:pPr>
                       <a:r>
                         <a:t>December on</a:t>
                       </a:r>
                     </a:p>
                   </a:txBody>
-                  <a:tcPr/>
+                  <a:tcPr>
+                    <a:solidFill>
+                      <a:srgbClr val="E5E7EB"/>
+                    </a:solidFill>
+                  </a:tcPr>
                 </a:tc>
                 <a:tc>
                   <a:txBody>
@@ -6979,14 +8225,23 @@
                     <a:lstStyle/>
                     <a:p>
                       <a:pPr>
-                        <a:defRPr sz="1800"/>
+                        <a:defRPr sz="1800" b="0">
+                          <a:solidFill>
+                            <a:srgbClr val="1A1A1A"/>
+                          </a:solidFill>
+                          <a:latin typeface="Segoe UI"/>
+                        </a:defRPr>
                       </a:pPr>
                       <a:r>
                         <a:t>Phase 3 at scale; consolidate thesis chapters</a:t>
                       </a:r>
                     </a:p>
                   </a:txBody>
-                  <a:tcPr/>
+                  <a:tcPr>
+                    <a:solidFill>
+                      <a:srgbClr val="E5E7EB"/>
+                    </a:solidFill>
+                  </a:tcPr>
                 </a:tc>
               </a:tr>
             </a:tbl>
@@ -7019,8 +8274,8 @@
         </p:nvSpPr>
         <p:spPr>
           <a:xfrm>
-            <a:off x="411480" y="228600"/>
-            <a:ext cx="11338560" cy="685800"/>
+            <a:off x="11430000" y="6446520"/>
+            <a:ext cx="640080" cy="320040"/>
           </a:xfrm>
           <a:prstGeom prst="rect">
             <a:avLst/>
@@ -7034,14 +8289,15 @@
           <a:lstStyle/>
           <a:p>
             <a:pPr>
-              <a:defRPr sz="2800" b="1">
-                <a:solidFill>
-                  <a:srgbClr val="1A1A1A"/>
-                </a:solidFill>
+              <a:defRPr sz="1200" b="0">
+                <a:solidFill>
+                  <a:srgbClr val="6B7280"/>
+                </a:solidFill>
+                <a:latin typeface="Segoe UI"/>
               </a:defRPr>
             </a:pPr>
             <a:r>
-              <a:t>Open questions</a:t>
+              <a:t>22</a:t>
             </a:r>
           </a:p>
         </p:txBody>
@@ -7054,6 +8310,86 @@
         </p:nvSpPr>
         <p:spPr>
           <a:xfrm>
+            <a:off x="411480" y="228600"/>
+            <a:ext cx="11338560" cy="685800"/>
+          </a:xfrm>
+          <a:prstGeom prst="rect">
+            <a:avLst/>
+          </a:prstGeom>
+          <a:noFill/>
+        </p:spPr>
+        <p:txBody>
+          <a:bodyPr wrap="none">
+            <a:spAutoFit/>
+          </a:bodyPr>
+          <a:lstStyle/>
+          <a:p>
+            <a:pPr>
+              <a:defRPr sz="2800" b="1">
+                <a:solidFill>
+                  <a:srgbClr val="1A1A1A"/>
+                </a:solidFill>
+                <a:latin typeface="Segoe UI"/>
+              </a:defRPr>
+            </a:pPr>
+            <a:r>
+              <a:t>Open questions</a:t>
+            </a:r>
+          </a:p>
+        </p:txBody>
+      </p:sp>
+      <p:sp>
+        <p:nvSpPr>
+          <p:cNvPr id="4" name="Rectangle 3"/>
+          <p:cNvSpPr/>
+          <p:nvPr/>
+        </p:nvSpPr>
+        <p:spPr>
+          <a:xfrm>
+            <a:off x="457200" y="896112"/>
+            <a:ext cx="11247120" cy="27940"/>
+          </a:xfrm>
+          <a:prstGeom prst="rect">
+            <a:avLst/>
+          </a:prstGeom>
+          <a:solidFill>
+            <a:srgbClr val="0072B2"/>
+          </a:solidFill>
+          <a:ln>
+            <a:noFill/>
+          </a:ln>
+          <a:effectLst/>
+        </p:spPr>
+        <p:style>
+          <a:lnRef idx="1">
+            <a:schemeClr val="accent1"/>
+          </a:lnRef>
+          <a:fillRef idx="3">
+            <a:schemeClr val="accent1"/>
+          </a:fillRef>
+          <a:effectRef idx="2">
+            <a:schemeClr val="accent1"/>
+          </a:effectRef>
+          <a:fontRef idx="minor">
+            <a:schemeClr val="lt1"/>
+          </a:fontRef>
+        </p:style>
+        <p:txBody>
+          <a:bodyPr rtlCol="0" anchor="ctr"/>
+          <a:lstStyle/>
+          <a:p>
+            <a:pPr algn="ctr"/>
+          </a:p>
+        </p:txBody>
+      </p:sp>
+      <p:sp>
+        <p:nvSpPr>
+          <p:cNvPr id="5" name="TextBox 4"/>
+          <p:cNvSpPr txBox="1"/>
+          <p:nvPr/>
+        </p:nvSpPr>
+        <p:spPr>
+          <a:xfrm>
             <a:off x="822960" y="1097280"/>
             <a:ext cx="10607040" cy="4389120"/>
           </a:xfrm>
@@ -7070,46 +8406,49 @@
           <a:p>
             <a:pPr>
               <a:spcAft>
-                <a:spcPts val="800"/>
+                <a:spcPts val="1000"/>
               </a:spcAft>
-              <a:defRPr sz="2000">
+              <a:defRPr sz="2000" b="0">
                 <a:solidFill>
                   <a:srgbClr val="1A1A1A"/>
                 </a:solidFill>
+                <a:latin typeface="Segoe UI"/>
               </a:defRPr>
             </a:pPr>
             <a:r>
-              <a:t>• Which corpus to confirm the timing result on: a new one (Bach10), a disclosed re-use, or both?</a:t>
+              <a:t>•  Which corpus to confirm the timing result on: a new one (Bach10), a disclosed re-use, or both?</a:t>
             </a:r>
           </a:p>
           <a:p>
             <a:pPr>
               <a:spcAft>
-                <a:spcPts val="800"/>
+                <a:spcPts val="1000"/>
               </a:spcAft>
-              <a:defRPr sz="2000">
+              <a:defRPr sz="2000" b="0">
                 <a:solidFill>
                   <a:srgbClr val="1A1A1A"/>
                 </a:solidFill>
+                <a:latin typeface="Segoe UI"/>
               </a:defRPr>
             </a:pPr>
             <a:r>
-              <a:t>• Keep the channels as three scalars per note, or move them to curve level (the prototype's direction)?</a:t>
+              <a:t>•  Keep the channels as three scalars per note, or move them to curve level (the prototype's direction)?</a:t>
             </a:r>
           </a:p>
           <a:p>
             <a:pPr>
               <a:spcAft>
-                <a:spcPts val="800"/>
+                <a:spcPts val="1000"/>
               </a:spcAft>
-              <a:defRPr sz="2000">
+              <a:defRPr sz="2000" b="0">
                 <a:solidFill>
                   <a:srgbClr val="1A1A1A"/>
                 </a:solidFill>
+                <a:latin typeface="Segoe UI"/>
               </a:defRPr>
             </a:pPr>
             <a:r>
-              <a:t>• Should the new robustness options become defaults?</a:t>
+              <a:t>•  Should the new robustness options become defaults?</a:t>
             </a:r>
           </a:p>
         </p:txBody>
@@ -7140,8 +8479,8 @@
         </p:nvSpPr>
         <p:spPr>
           <a:xfrm>
-            <a:off x="411480" y="228600"/>
-            <a:ext cx="11338560" cy="685800"/>
+            <a:off x="11430000" y="6446520"/>
+            <a:ext cx="640080" cy="320040"/>
           </a:xfrm>
           <a:prstGeom prst="rect">
             <a:avLst/>
@@ -7155,14 +8494,15 @@
           <a:lstStyle/>
           <a:p>
             <a:pPr>
-              <a:defRPr sz="2800" b="1">
-                <a:solidFill>
-                  <a:srgbClr val="1A1A1A"/>
-                </a:solidFill>
+              <a:defRPr sz="1200" b="0">
+                <a:solidFill>
+                  <a:srgbClr val="6B7280"/>
+                </a:solidFill>
+                <a:latin typeface="Segoe UI"/>
               </a:defRPr>
             </a:pPr>
             <a:r>
-              <a:t>The thesis, and the three problems</a:t>
+              <a:t>3</a:t>
             </a:r>
           </a:p>
         </p:txBody>
@@ -7175,6 +8515,86 @@
         </p:nvSpPr>
         <p:spPr>
           <a:xfrm>
+            <a:off x="411480" y="228600"/>
+            <a:ext cx="11338560" cy="685800"/>
+          </a:xfrm>
+          <a:prstGeom prst="rect">
+            <a:avLst/>
+          </a:prstGeom>
+          <a:noFill/>
+        </p:spPr>
+        <p:txBody>
+          <a:bodyPr wrap="none">
+            <a:spAutoFit/>
+          </a:bodyPr>
+          <a:lstStyle/>
+          <a:p>
+            <a:pPr>
+              <a:defRPr sz="2800" b="1">
+                <a:solidFill>
+                  <a:srgbClr val="1A1A1A"/>
+                </a:solidFill>
+                <a:latin typeface="Segoe UI"/>
+              </a:defRPr>
+            </a:pPr>
+            <a:r>
+              <a:t>The thesis, and the three problems</a:t>
+            </a:r>
+          </a:p>
+        </p:txBody>
+      </p:sp>
+      <p:sp>
+        <p:nvSpPr>
+          <p:cNvPr id="4" name="Rectangle 3"/>
+          <p:cNvSpPr/>
+          <p:nvPr/>
+        </p:nvSpPr>
+        <p:spPr>
+          <a:xfrm>
+            <a:off x="457200" y="896112"/>
+            <a:ext cx="11247120" cy="27940"/>
+          </a:xfrm>
+          <a:prstGeom prst="rect">
+            <a:avLst/>
+          </a:prstGeom>
+          <a:solidFill>
+            <a:srgbClr val="0072B2"/>
+          </a:solidFill>
+          <a:ln>
+            <a:noFill/>
+          </a:ln>
+          <a:effectLst/>
+        </p:spPr>
+        <p:style>
+          <a:lnRef idx="1">
+            <a:schemeClr val="accent1"/>
+          </a:lnRef>
+          <a:fillRef idx="3">
+            <a:schemeClr val="accent1"/>
+          </a:fillRef>
+          <a:effectRef idx="2">
+            <a:schemeClr val="accent1"/>
+          </a:effectRef>
+          <a:fontRef idx="minor">
+            <a:schemeClr val="lt1"/>
+          </a:fontRef>
+        </p:style>
+        <p:txBody>
+          <a:bodyPr rtlCol="0" anchor="ctr"/>
+          <a:lstStyle/>
+          <a:p>
+            <a:pPr algn="ctr"/>
+          </a:p>
+        </p:txBody>
+      </p:sp>
+      <p:sp>
+        <p:nvSpPr>
+          <p:cNvPr id="5" name="TextBox 4"/>
+          <p:cNvSpPr txBox="1"/>
+          <p:nvPr/>
+        </p:nvSpPr>
+        <p:spPr>
+          <a:xfrm>
             <a:off x="822960" y="1097280"/>
             <a:ext cx="10607040" cy="4389120"/>
           </a:xfrm>
@@ -7191,61 +8611,65 @@
           <a:p>
             <a:pPr>
               <a:spcAft>
-                <a:spcPts val="800"/>
+                <a:spcPts val="1000"/>
               </a:spcAft>
-              <a:defRPr sz="2000">
+              <a:defRPr sz="2000" b="0">
                 <a:solidFill>
                   <a:srgbClr val="1A1A1A"/>
                 </a:solidFill>
+                <a:latin typeface="Segoe UI"/>
               </a:defRPr>
             </a:pPr>
             <a:r>
-              <a:t>• Thesis: one Gaussian process on the score graph turns a known score and a performance into per-note expressive variables, each with an error bar you can trust.</a:t>
+              <a:t>•  Thesis: one Gaussian process on the score graph turns a known score and a performance into per-note expressive variables, each with an error bar you can trust.</a:t>
             </a:r>
           </a:p>
           <a:p>
             <a:pPr>
               <a:spcAft>
-                <a:spcPts val="800"/>
+                <a:spcPts val="1000"/>
               </a:spcAft>
-              <a:defRPr sz="2000">
+              <a:defRPr sz="2000" b="0">
                 <a:solidFill>
                   <a:srgbClr val="1A1A1A"/>
                 </a:solidFill>
+                <a:latin typeface="Segoe UI"/>
               </a:defRPr>
             </a:pPr>
             <a:r>
-              <a:t>• Piano: timing, articulation, velocity, read directly from aligned MIDI. Are the error bars calibrated?</a:t>
+              <a:t>•  Piano: timing, articulation, velocity, read directly from aligned MIDI. Are the error bars calibrated?</a:t>
             </a:r>
           </a:p>
           <a:p>
             <a:pPr>
               <a:spcAft>
-                <a:spcPts val="800"/>
+                <a:spcPts val="1000"/>
               </a:spcAft>
-              <a:defRPr sz="2000">
+              <a:defRPr sz="2000" b="0">
                 <a:solidFill>
                   <a:srgbClr val="1A1A1A"/>
                 </a:solidFill>
+                <a:latin typeface="Segoe UI"/>
               </a:defRPr>
             </a:pPr>
             <a:r>
-              <a:t>• Strings and winds: six variables, now with intonation and vibrato, estimated from audio, noisily. Does the same prior still work?</a:t>
+              <a:t>•  Strings and winds: six variables, now with intonation and vibrato, estimated from audio, noisily. Does the same prior still work?</a:t>
             </a:r>
           </a:p>
           <a:p>
             <a:pPr>
               <a:spcAft>
-                <a:spcPts val="800"/>
+                <a:spcPts val="1000"/>
               </a:spcAft>
-              <a:defRPr sz="2000">
+              <a:defRPr sz="2000" b="0">
                 <a:solidFill>
                   <a:srgbClr val="1A1A1A"/>
                 </a:solidFill>
+                <a:latin typeface="Segoe UI"/>
               </a:defRPr>
             </a:pPr>
             <a:r>
-              <a:t>• Audio directly: no pitch tracker at all. Can the waveform itself be the observation?</a:t>
+              <a:t>•  Audio directly: no pitch tracker at all. Can the waveform itself be the observation?</a:t>
             </a:r>
           </a:p>
         </p:txBody>
@@ -7276,8 +8700,8 @@
         </p:nvSpPr>
         <p:spPr>
           <a:xfrm>
-            <a:off x="411480" y="228600"/>
-            <a:ext cx="11338560" cy="685800"/>
+            <a:off x="11430000" y="6446520"/>
+            <a:ext cx="640080" cy="320040"/>
           </a:xfrm>
           <a:prstGeom prst="rect">
             <a:avLst/>
@@ -7291,14 +8715,15 @@
           <a:lstStyle/>
           <a:p>
             <a:pPr>
-              <a:defRPr sz="2800" b="1">
-                <a:solidFill>
-                  <a:srgbClr val="1A1A1A"/>
-                </a:solidFill>
+              <a:defRPr sz="1200" b="0">
+                <a:solidFill>
+                  <a:srgbClr val="6B7280"/>
+                </a:solidFill>
+                <a:latin typeface="Segoe UI"/>
               </a:defRPr>
             </a:pPr>
             <a:r>
-              <a:t>Approach: one prior, three kinds of observation</a:t>
+              <a:t>4</a:t>
             </a:r>
           </a:p>
         </p:txBody>
@@ -7311,6 +8736,86 @@
         </p:nvSpPr>
         <p:spPr>
           <a:xfrm>
+            <a:off x="411480" y="228600"/>
+            <a:ext cx="11338560" cy="685800"/>
+          </a:xfrm>
+          <a:prstGeom prst="rect">
+            <a:avLst/>
+          </a:prstGeom>
+          <a:noFill/>
+        </p:spPr>
+        <p:txBody>
+          <a:bodyPr wrap="none">
+            <a:spAutoFit/>
+          </a:bodyPr>
+          <a:lstStyle/>
+          <a:p>
+            <a:pPr>
+              <a:defRPr sz="2800" b="1">
+                <a:solidFill>
+                  <a:srgbClr val="1A1A1A"/>
+                </a:solidFill>
+                <a:latin typeface="Segoe UI"/>
+              </a:defRPr>
+            </a:pPr>
+            <a:r>
+              <a:t>Approach: one prior, three kinds of observation</a:t>
+            </a:r>
+          </a:p>
+        </p:txBody>
+      </p:sp>
+      <p:sp>
+        <p:nvSpPr>
+          <p:cNvPr id="4" name="Rectangle 3"/>
+          <p:cNvSpPr/>
+          <p:nvPr/>
+        </p:nvSpPr>
+        <p:spPr>
+          <a:xfrm>
+            <a:off x="457200" y="896112"/>
+            <a:ext cx="11247120" cy="27940"/>
+          </a:xfrm>
+          <a:prstGeom prst="rect">
+            <a:avLst/>
+          </a:prstGeom>
+          <a:solidFill>
+            <a:srgbClr val="0072B2"/>
+          </a:solidFill>
+          <a:ln>
+            <a:noFill/>
+          </a:ln>
+          <a:effectLst/>
+        </p:spPr>
+        <p:style>
+          <a:lnRef idx="1">
+            <a:schemeClr val="accent1"/>
+          </a:lnRef>
+          <a:fillRef idx="3">
+            <a:schemeClr val="accent1"/>
+          </a:fillRef>
+          <a:effectRef idx="2">
+            <a:schemeClr val="accent1"/>
+          </a:effectRef>
+          <a:fontRef idx="minor">
+            <a:schemeClr val="lt1"/>
+          </a:fontRef>
+        </p:style>
+        <p:txBody>
+          <a:bodyPr rtlCol="0" anchor="ctr"/>
+          <a:lstStyle/>
+          <a:p>
+            <a:pPr algn="ctr"/>
+          </a:p>
+        </p:txBody>
+      </p:sp>
+      <p:sp>
+        <p:nvSpPr>
+          <p:cNvPr id="5" name="TextBox 4"/>
+          <p:cNvSpPr txBox="1"/>
+          <p:nvPr/>
+        </p:nvSpPr>
+        <p:spPr>
+          <a:xfrm>
             <a:off x="822960" y="1097280"/>
             <a:ext cx="10607040" cy="4389120"/>
           </a:xfrm>
@@ -7327,23 +8832,24 @@
           <a:p>
             <a:pPr>
               <a:spcAft>
-                <a:spcPts val="800"/>
+                <a:spcPts val="1000"/>
               </a:spcAft>
-              <a:defRPr sz="2000">
+              <a:defRPr sz="2000" b="0">
                 <a:solidFill>
                   <a:srgbClr val="1A1A1A"/>
                 </a:solidFill>
+                <a:latin typeface="Segoe UI"/>
               </a:defRPr>
             </a:pPr>
             <a:r>
-              <a:t>• One GP prior over per-note expressive fields, on a graph built from the score. Only the observation changes per phase: MIDI, f0 targets, or the waveform.</a:t>
+              <a:t>•  One GP prior over per-note expressive fields, on a graph built from the score. Only the observation changes per phase: MIDI, f0 targets, or the waveform.</a:t>
             </a:r>
           </a:p>
         </p:txBody>
       </p:sp>
       <p:pic>
         <p:nvPicPr>
-          <p:cNvPr id="4" name="Picture 3" descr="deck_programme.png"/>
+          <p:cNvPr id="6" name="Picture 5" descr="deck_programme.png"/>
           <p:cNvPicPr>
             <a:picLocks noChangeAspect="1"/>
           </p:cNvPicPr>
@@ -7391,8 +8897,8 @@
         </p:nvSpPr>
         <p:spPr>
           <a:xfrm>
-            <a:off x="411480" y="228600"/>
-            <a:ext cx="11338560" cy="685800"/>
+            <a:off x="11430000" y="6446520"/>
+            <a:ext cx="640080" cy="320040"/>
           </a:xfrm>
           <a:prstGeom prst="rect">
             <a:avLst/>
@@ -7406,14 +8912,15 @@
           <a:lstStyle/>
           <a:p>
             <a:pPr>
-              <a:defRPr sz="2800" b="1">
-                <a:solidFill>
-                  <a:srgbClr val="1A1A1A"/>
-                </a:solidFill>
+              <a:defRPr sz="1200" b="0">
+                <a:solidFill>
+                  <a:srgbClr val="6B7280"/>
+                </a:solidFill>
+                <a:latin typeface="Segoe UI"/>
               </a:defRPr>
             </a:pPr>
             <a:r>
-              <a:t>The model (1): the score graph</a:t>
+              <a:t>5</a:t>
             </a:r>
           </a:p>
         </p:txBody>
@@ -7426,8 +8933,8 @@
         </p:nvSpPr>
         <p:spPr>
           <a:xfrm>
-            <a:off x="822960" y="1097280"/>
-            <a:ext cx="10515600" cy="640080"/>
+            <a:off x="411480" y="228600"/>
+            <a:ext cx="11338560" cy="685800"/>
           </a:xfrm>
           <a:prstGeom prst="rect">
             <a:avLst/>
@@ -7441,10 +8948,91 @@
           <a:lstStyle/>
           <a:p>
             <a:pPr>
-              <a:defRPr sz="2000">
+              <a:defRPr sz="2800" b="1">
+                <a:solidFill>
+                  <a:srgbClr val="1A1A1A"/>
+                </a:solidFill>
+                <a:latin typeface="Segoe UI"/>
+              </a:defRPr>
+            </a:pPr>
+            <a:r>
+              <a:t>The model (1): the score graph</a:t>
+            </a:r>
+          </a:p>
+        </p:txBody>
+      </p:sp>
+      <p:sp>
+        <p:nvSpPr>
+          <p:cNvPr id="4" name="Rectangle 3"/>
+          <p:cNvSpPr/>
+          <p:nvPr/>
+        </p:nvSpPr>
+        <p:spPr>
+          <a:xfrm>
+            <a:off x="457200" y="896112"/>
+            <a:ext cx="11247120" cy="27940"/>
+          </a:xfrm>
+          <a:prstGeom prst="rect">
+            <a:avLst/>
+          </a:prstGeom>
+          <a:solidFill>
+            <a:srgbClr val="0072B2"/>
+          </a:solidFill>
+          <a:ln>
+            <a:noFill/>
+          </a:ln>
+          <a:effectLst/>
+        </p:spPr>
+        <p:style>
+          <a:lnRef idx="1">
+            <a:schemeClr val="accent1"/>
+          </a:lnRef>
+          <a:fillRef idx="3">
+            <a:schemeClr val="accent1"/>
+          </a:fillRef>
+          <a:effectRef idx="2">
+            <a:schemeClr val="accent1"/>
+          </a:effectRef>
+          <a:fontRef idx="minor">
+            <a:schemeClr val="lt1"/>
+          </a:fontRef>
+        </p:style>
+        <p:txBody>
+          <a:bodyPr rtlCol="0" anchor="ctr"/>
+          <a:lstStyle/>
+          <a:p>
+            <a:pPr algn="ctr"/>
+          </a:p>
+        </p:txBody>
+      </p:sp>
+      <p:sp>
+        <p:nvSpPr>
+          <p:cNvPr id="5" name="TextBox 4"/>
+          <p:cNvSpPr txBox="1"/>
+          <p:nvPr/>
+        </p:nvSpPr>
+        <p:spPr>
+          <a:xfrm>
+            <a:off x="822960" y="1097280"/>
+            <a:ext cx="10515600" cy="640080"/>
+          </a:xfrm>
+          <a:prstGeom prst="rect">
+            <a:avLst/>
+          </a:prstGeom>
+          <a:noFill/>
+        </p:spPr>
+        <p:txBody>
+          <a:bodyPr wrap="none">
+            <a:spAutoFit/>
+          </a:bodyPr>
+          <a:lstStyle/>
+          <a:p>
+            <a:pPr>
+              <a:defRPr sz="2000" b="0">
                 <a:solidFill>
                   <a:srgbClr val="0072B2"/>
                 </a:solidFill>
+                <a:latin typeface="Segoe UI"/>
               </a:defRPr>
             </a:pPr>
             <a:r>
@@ -7455,7 +9043,7 @@
       </p:sp>
       <p:sp>
         <p:nvSpPr>
-          <p:cNvPr id="4" name="TextBox 3"/>
+          <p:cNvPr id="6" name="TextBox 5"/>
           <p:cNvSpPr txBox="1"/>
           <p:nvPr/>
         </p:nvSpPr>
@@ -7477,38 +9065,40 @@
           <a:p>
             <a:pPr>
               <a:spcAft>
-                <a:spcPts val="800"/>
+                <a:spcPts val="1000"/>
               </a:spcAft>
-              <a:defRPr sz="2000">
+              <a:defRPr sz="2000" b="0">
                 <a:solidFill>
                   <a:srgbClr val="1A1A1A"/>
                 </a:solidFill>
+                <a:latin typeface="Segoe UI"/>
               </a:defRPr>
             </a:pPr>
             <a:r>
-              <a:t>• Nodes: the written notes (pitch, beat onset, duration).</a:t>
+              <a:t>•  Nodes: the written notes (pitch, beat onset, duration).</a:t>
             </a:r>
           </a:p>
           <a:p>
             <a:pPr>
               <a:spcAft>
-                <a:spcPts val="800"/>
+                <a:spcPts val="1000"/>
               </a:spcAft>
-              <a:defRPr sz="2000">
+              <a:defRPr sz="2000" b="0">
                 <a:solidFill>
                   <a:srgbClr val="1A1A1A"/>
                 </a:solidFill>
+                <a:latin typeface="Segoe UI"/>
               </a:defRPr>
             </a:pPr>
             <a:r>
-              <a:t>• Edges: close in score time and pitch — neighbours are played similarly.</a:t>
+              <a:t>•  Edges: close in score time and pitch — neighbours are played similarly.</a:t>
             </a:r>
           </a:p>
         </p:txBody>
       </p:sp>
       <p:pic>
         <p:nvPicPr>
-          <p:cNvPr id="5" name="Picture 4" descr="deck_scoregraph.png"/>
+          <p:cNvPr id="7" name="Picture 6" descr="deck_scoregraph.png"/>
           <p:cNvPicPr>
             <a:picLocks noChangeAspect="1"/>
           </p:cNvPicPr>
@@ -7556,8 +9146,8 @@
         </p:nvSpPr>
         <p:spPr>
           <a:xfrm>
-            <a:off x="411480" y="228600"/>
-            <a:ext cx="11338560" cy="685800"/>
+            <a:off x="11430000" y="6446520"/>
+            <a:ext cx="640080" cy="320040"/>
           </a:xfrm>
           <a:prstGeom prst="rect">
             <a:avLst/>
@@ -7571,14 +9161,15 @@
           <a:lstStyle/>
           <a:p>
             <a:pPr>
-              <a:defRPr sz="2800" b="1">
-                <a:solidFill>
-                  <a:srgbClr val="1A1A1A"/>
-                </a:solidFill>
+              <a:defRPr sz="1200" b="0">
+                <a:solidFill>
+                  <a:srgbClr val="6B7280"/>
+                </a:solidFill>
+                <a:latin typeface="Segoe UI"/>
               </a:defRPr>
             </a:pPr>
             <a:r>
-              <a:t>The model (2): a GP on the graph, channels coupled</a:t>
+              <a:t>6</a:t>
             </a:r>
           </a:p>
         </p:txBody>
@@ -7591,8 +9182,8 @@
         </p:nvSpPr>
         <p:spPr>
           <a:xfrm>
-            <a:off x="822960" y="1097280"/>
-            <a:ext cx="10515600" cy="640080"/>
+            <a:off x="411480" y="228600"/>
+            <a:ext cx="11338560" cy="685800"/>
           </a:xfrm>
           <a:prstGeom prst="rect">
             <a:avLst/>
@@ -7606,10 +9197,91 @@
           <a:lstStyle/>
           <a:p>
             <a:pPr>
-              <a:defRPr sz="2000">
+              <a:defRPr sz="2800" b="1">
+                <a:solidFill>
+                  <a:srgbClr val="1A1A1A"/>
+                </a:solidFill>
+                <a:latin typeface="Segoe UI"/>
+              </a:defRPr>
+            </a:pPr>
+            <a:r>
+              <a:t>The model (2): a GP on the graph, channels coupled</a:t>
+            </a:r>
+          </a:p>
+        </p:txBody>
+      </p:sp>
+      <p:sp>
+        <p:nvSpPr>
+          <p:cNvPr id="4" name="Rectangle 3"/>
+          <p:cNvSpPr/>
+          <p:nvPr/>
+        </p:nvSpPr>
+        <p:spPr>
+          <a:xfrm>
+            <a:off x="457200" y="896112"/>
+            <a:ext cx="11247120" cy="27940"/>
+          </a:xfrm>
+          <a:prstGeom prst="rect">
+            <a:avLst/>
+          </a:prstGeom>
+          <a:solidFill>
+            <a:srgbClr val="0072B2"/>
+          </a:solidFill>
+          <a:ln>
+            <a:noFill/>
+          </a:ln>
+          <a:effectLst/>
+        </p:spPr>
+        <p:style>
+          <a:lnRef idx="1">
+            <a:schemeClr val="accent1"/>
+          </a:lnRef>
+          <a:fillRef idx="3">
+            <a:schemeClr val="accent1"/>
+          </a:fillRef>
+          <a:effectRef idx="2">
+            <a:schemeClr val="accent1"/>
+          </a:effectRef>
+          <a:fontRef idx="minor">
+            <a:schemeClr val="lt1"/>
+          </a:fontRef>
+        </p:style>
+        <p:txBody>
+          <a:bodyPr rtlCol="0" anchor="ctr"/>
+          <a:lstStyle/>
+          <a:p>
+            <a:pPr algn="ctr"/>
+          </a:p>
+        </p:txBody>
+      </p:sp>
+      <p:sp>
+        <p:nvSpPr>
+          <p:cNvPr id="5" name="TextBox 4"/>
+          <p:cNvSpPr txBox="1"/>
+          <p:nvPr/>
+        </p:nvSpPr>
+        <p:spPr>
+          <a:xfrm>
+            <a:off x="822960" y="1097280"/>
+            <a:ext cx="10515600" cy="640080"/>
+          </a:xfrm>
+          <a:prstGeom prst="rect">
+            <a:avLst/>
+          </a:prstGeom>
+          <a:noFill/>
+        </p:spPr>
+        <p:txBody>
+          <a:bodyPr wrap="none">
+            <a:spAutoFit/>
+          </a:bodyPr>
+          <a:lstStyle/>
+          <a:p>
+            <a:pPr>
+              <a:defRPr sz="2000" b="0">
                 <a:solidFill>
                   <a:srgbClr val="0072B2"/>
                 </a:solidFill>
+                <a:latin typeface="Segoe UI"/>
               </a:defRPr>
             </a:pPr>
             <a:r>
@@ -7620,7 +9292,7 @@
       </p:sp>
       <p:sp>
         <p:nvSpPr>
-          <p:cNvPr id="4" name="TextBox 3"/>
+          <p:cNvPr id="6" name="TextBox 5"/>
           <p:cNvSpPr txBox="1"/>
           <p:nvPr/>
         </p:nvSpPr>
@@ -7642,31 +9314,33 @@
           <a:p>
             <a:pPr>
               <a:spcAft>
-                <a:spcPts val="800"/>
+                <a:spcPts val="1000"/>
               </a:spcAft>
-              <a:defRPr sz="2000">
+              <a:defRPr sz="2000" b="0">
                 <a:solidFill>
                   <a:srgbClr val="1A1A1A"/>
                 </a:solidFill>
+                <a:latin typeface="Segoe UI"/>
               </a:defRPr>
             </a:pPr>
             <a:r>
-              <a:t>• Shape the Laplacian spectrum with one parameter s: smooth-on-the-graph patterns keep their variance, rough ones are shrunk (graph Matérn).</a:t>
+              <a:t>•  Shape the Laplacian spectrum with one parameter s: smooth-on-the-graph patterns keep their variance, rough ones are shrunk (graph Matérn).</a:t>
             </a:r>
           </a:p>
           <a:p>
             <a:pPr>
               <a:spcAft>
-                <a:spcPts val="800"/>
+                <a:spcPts val="1000"/>
               </a:spcAft>
-              <a:defRPr sz="2000">
+              <a:defRPr sz="2000" b="0">
                 <a:solidFill>
                   <a:srgbClr val="1A1A1A"/>
                 </a:solidFill>
+                <a:latin typeface="Segoe UI"/>
               </a:defRPr>
             </a:pPr>
             <a:r>
-              <a:t>• The channels are correlated: a learned coupling matrix B shares the graph, so an observed channel at one note informs the others at neighbouring notes.</a:t>
+              <a:t>•  The channels are correlated: a learned coupling matrix B shares the graph, so an observed channel at one note informs the others at neighbouring notes.</a:t>
             </a:r>
           </a:p>
         </p:txBody>
@@ -7697,8 +9371,8 @@
         </p:nvSpPr>
         <p:spPr>
           <a:xfrm>
-            <a:off x="411480" y="228600"/>
-            <a:ext cx="11338560" cy="685800"/>
+            <a:off x="11430000" y="6446520"/>
+            <a:ext cx="640080" cy="320040"/>
           </a:xfrm>
           <a:prstGeom prst="rect">
             <a:avLst/>
@@ -7712,14 +9386,15 @@
           <a:lstStyle/>
           <a:p>
             <a:pPr>
-              <a:defRPr sz="2800" b="1">
-                <a:solidFill>
-                  <a:srgbClr val="1A1A1A"/>
-                </a:solidFill>
+              <a:defRPr sz="1200" b="0">
+                <a:solidFill>
+                  <a:srgbClr val="6B7280"/>
+                </a:solidFill>
+                <a:latin typeface="Segoe UI"/>
               </a:defRPr>
             </a:pPr>
             <a:r>
-              <a:t>The model (3): the covariance of one performance</a:t>
+              <a:t>7</a:t>
             </a:r>
           </a:p>
         </p:txBody>
@@ -7732,8 +9407,8 @@
         </p:nvSpPr>
         <p:spPr>
           <a:xfrm>
-            <a:off x="822960" y="1097280"/>
-            <a:ext cx="10515600" cy="640080"/>
+            <a:off x="411480" y="228600"/>
+            <a:ext cx="11338560" cy="685800"/>
           </a:xfrm>
           <a:prstGeom prst="rect">
             <a:avLst/>
@@ -7747,10 +9422,91 @@
           <a:lstStyle/>
           <a:p>
             <a:pPr>
-              <a:defRPr sz="2000">
+              <a:defRPr sz="2800" b="1">
+                <a:solidFill>
+                  <a:srgbClr val="1A1A1A"/>
+                </a:solidFill>
+                <a:latin typeface="Segoe UI"/>
+              </a:defRPr>
+            </a:pPr>
+            <a:r>
+              <a:t>The model (3): the covariance of one performance</a:t>
+            </a:r>
+          </a:p>
+        </p:txBody>
+      </p:sp>
+      <p:sp>
+        <p:nvSpPr>
+          <p:cNvPr id="4" name="Rectangle 3"/>
+          <p:cNvSpPr/>
+          <p:nvPr/>
+        </p:nvSpPr>
+        <p:spPr>
+          <a:xfrm>
+            <a:off x="457200" y="896112"/>
+            <a:ext cx="11247120" cy="27940"/>
+          </a:xfrm>
+          <a:prstGeom prst="rect">
+            <a:avLst/>
+          </a:prstGeom>
+          <a:solidFill>
+            <a:srgbClr val="0072B2"/>
+          </a:solidFill>
+          <a:ln>
+            <a:noFill/>
+          </a:ln>
+          <a:effectLst/>
+        </p:spPr>
+        <p:style>
+          <a:lnRef idx="1">
+            <a:schemeClr val="accent1"/>
+          </a:lnRef>
+          <a:fillRef idx="3">
+            <a:schemeClr val="accent1"/>
+          </a:fillRef>
+          <a:effectRef idx="2">
+            <a:schemeClr val="accent1"/>
+          </a:effectRef>
+          <a:fontRef idx="minor">
+            <a:schemeClr val="lt1"/>
+          </a:fontRef>
+        </p:style>
+        <p:txBody>
+          <a:bodyPr rtlCol="0" anchor="ctr"/>
+          <a:lstStyle/>
+          <a:p>
+            <a:pPr algn="ctr"/>
+          </a:p>
+        </p:txBody>
+      </p:sp>
+      <p:sp>
+        <p:nvSpPr>
+          <p:cNvPr id="5" name="TextBox 4"/>
+          <p:cNvSpPr txBox="1"/>
+          <p:nvPr/>
+        </p:nvSpPr>
+        <p:spPr>
+          <a:xfrm>
+            <a:off x="822960" y="1097280"/>
+            <a:ext cx="10515600" cy="640080"/>
+          </a:xfrm>
+          <a:prstGeom prst="rect">
+            <a:avLst/>
+          </a:prstGeom>
+          <a:noFill/>
+        </p:spPr>
+        <p:txBody>
+          <a:bodyPr wrap="none">
+            <a:spAutoFit/>
+          </a:bodyPr>
+          <a:lstStyle/>
+          <a:p>
+            <a:pPr>
+              <a:defRPr sz="2000" b="0">
                 <a:solidFill>
                   <a:srgbClr val="0072B2"/>
                 </a:solidFill>
+                <a:latin typeface="Segoe UI"/>
               </a:defRPr>
             </a:pPr>
             <a:r>
@@ -7761,7 +9517,7 @@
       </p:sp>
       <p:sp>
         <p:nvSpPr>
-          <p:cNvPr id="4" name="TextBox 3"/>
+          <p:cNvPr id="6" name="TextBox 5"/>
           <p:cNvSpPr txBox="1"/>
           <p:nvPr/>
         </p:nvSpPr>
@@ -7783,46 +9539,49 @@
           <a:p>
             <a:pPr>
               <a:spcAft>
-                <a:spcPts val="800"/>
+                <a:spcPts val="1000"/>
               </a:spcAft>
-              <a:defRPr sz="2000">
+              <a:defRPr sz="2000" b="0">
                 <a:solidFill>
                   <a:srgbClr val="1A1A1A"/>
                 </a:solidFill>
+                <a:latin typeface="Segoe UI"/>
               </a:defRPr>
             </a:pPr>
             <a:r>
-              <a:t>• Graph term + side-information terms + noise: the whole model is one per-piece covariance matrix.</a:t>
+              <a:t>•  Graph term + side-information terms + noise: the whole model is one per-piece covariance matrix.</a:t>
             </a:r>
           </a:p>
           <a:p>
             <a:pPr>
               <a:spcAft>
-                <a:spcPts val="800"/>
+                <a:spcPts val="1000"/>
               </a:spcAft>
-              <a:defRPr sz="2000">
+              <a:defRPr sz="2000" b="0">
                 <a:solidFill>
                   <a:srgbClr val="1A1A1A"/>
                 </a:solidFill>
+                <a:latin typeface="Segoe UI"/>
               </a:defRPr>
             </a:pPr>
             <a:r>
-              <a:t>• Feature weights are re-inferred for every piece — the measured source of the accuracy gain.</a:t>
+              <a:t>•  Feature weights are re-inferred for every piece — the measured source of the accuracy gain.</a:t>
             </a:r>
           </a:p>
           <a:p>
             <a:pPr>
               <a:spcAft>
-                <a:spcPts val="800"/>
+                <a:spcPts val="1000"/>
               </a:spcAft>
-              <a:defRPr sz="2000">
+              <a:defRPr sz="2000" b="0">
                 <a:solidFill>
                   <a:srgbClr val="1A1A1A"/>
                 </a:solidFill>
+                <a:latin typeface="Segoe UI"/>
               </a:defRPr>
             </a:pPr>
             <a:r>
-              <a:t>• Sixteen numbers per piece, fit by exact evidence; prediction is conjugate, closed form.</a:t>
+              <a:t>•  Sixteen numbers per piece, fit by exact evidence; prediction is conjugate, closed form.</a:t>
             </a:r>
           </a:p>
         </p:txBody>
@@ -7853,8 +9612,8 @@
         </p:nvSpPr>
         <p:spPr>
           <a:xfrm>
-            <a:off x="411480" y="228600"/>
-            <a:ext cx="11338560" cy="685800"/>
+            <a:off x="11430000" y="6446520"/>
+            <a:ext cx="640080" cy="320040"/>
           </a:xfrm>
           <a:prstGeom prst="rect">
             <a:avLst/>
@@ -7868,21 +9627,102 @@
           <a:lstStyle/>
           <a:p>
             <a:pPr>
+              <a:defRPr sz="1200" b="0">
+                <a:solidFill>
+                  <a:srgbClr val="6B7280"/>
+                </a:solidFill>
+                <a:latin typeface="Segoe UI"/>
+              </a:defRPr>
+            </a:pPr>
+            <a:r>
+              <a:t>8</a:t>
+            </a:r>
+          </a:p>
+        </p:txBody>
+      </p:sp>
+      <p:sp>
+        <p:nvSpPr>
+          <p:cNvPr id="3" name="TextBox 2"/>
+          <p:cNvSpPr txBox="1"/>
+          <p:nvPr/>
+        </p:nvSpPr>
+        <p:spPr>
+          <a:xfrm>
+            <a:off x="411480" y="228600"/>
+            <a:ext cx="11338560" cy="685800"/>
+          </a:xfrm>
+          <a:prstGeom prst="rect">
+            <a:avLst/>
+          </a:prstGeom>
+          <a:noFill/>
+        </p:spPr>
+        <p:txBody>
+          <a:bodyPr wrap="none">
+            <a:spAutoFit/>
+          </a:bodyPr>
+          <a:lstStyle/>
+          <a:p>
+            <a:pPr>
               <a:defRPr sz="2800" b="1">
                 <a:solidFill>
                   <a:srgbClr val="1A1A1A"/>
                 </a:solidFill>
+                <a:latin typeface="Segoe UI"/>
               </a:defRPr>
             </a:pPr>
             <a:r>
               <a:t>The model, in one picture</a:t>
             </a:r>
+          </a:p>
+        </p:txBody>
+      </p:sp>
+      <p:sp>
+        <p:nvSpPr>
+          <p:cNvPr id="4" name="Rectangle 3"/>
+          <p:cNvSpPr/>
+          <p:nvPr/>
+        </p:nvSpPr>
+        <p:spPr>
+          <a:xfrm>
+            <a:off x="457200" y="896112"/>
+            <a:ext cx="11247120" cy="27940"/>
+          </a:xfrm>
+          <a:prstGeom prst="rect">
+            <a:avLst/>
+          </a:prstGeom>
+          <a:solidFill>
+            <a:srgbClr val="0072B2"/>
+          </a:solidFill>
+          <a:ln>
+            <a:noFill/>
+          </a:ln>
+          <a:effectLst/>
+        </p:spPr>
+        <p:style>
+          <a:lnRef idx="1">
+            <a:schemeClr val="accent1"/>
+          </a:lnRef>
+          <a:fillRef idx="3">
+            <a:schemeClr val="accent1"/>
+          </a:fillRef>
+          <a:effectRef idx="2">
+            <a:schemeClr val="accent1"/>
+          </a:effectRef>
+          <a:fontRef idx="minor">
+            <a:schemeClr val="lt1"/>
+          </a:fontRef>
+        </p:style>
+        <p:txBody>
+          <a:bodyPr rtlCol="0" anchor="ctr"/>
+          <a:lstStyle/>
+          <a:p>
+            <a:pPr algn="ctr"/>
           </a:p>
         </p:txBody>
       </p:sp>
       <p:pic>
         <p:nvPicPr>
-          <p:cNvPr id="3" name="Picture 2" descr="arch_phase1_deck.png"/>
+          <p:cNvPr id="5" name="Picture 4" descr="arch_phase1_deck.png"/>
           <p:cNvPicPr>
             <a:picLocks noChangeAspect="1"/>
           </p:cNvPicPr>
@@ -7906,7 +9746,7 @@
       </p:pic>
       <p:sp>
         <p:nvSpPr>
-          <p:cNvPr id="4" name="TextBox 3"/>
+          <p:cNvPr id="6" name="TextBox 5"/>
           <p:cNvSpPr txBox="1"/>
           <p:nvPr/>
         </p:nvSpPr>
@@ -7927,10 +9767,11 @@
           <a:lstStyle/>
           <a:p>
             <a:pPr>
-              <a:defRPr sz="1300">
+              <a:defRPr sz="1300" b="0">
                 <a:solidFill>
                   <a:srgbClr val="6B7280"/>
                 </a:solidFill>
+                <a:latin typeface="Segoe UI"/>
               </a:defRPr>
             </a:pPr>
             <a:r>
@@ -7965,8 +9806,8 @@
         </p:nvSpPr>
         <p:spPr>
           <a:xfrm>
-            <a:off x="411480" y="228600"/>
-            <a:ext cx="11338560" cy="685800"/>
+            <a:off x="11430000" y="6446520"/>
+            <a:ext cx="640080" cy="320040"/>
           </a:xfrm>
           <a:prstGeom prst="rect">
             <a:avLst/>
@@ -7980,14 +9821,15 @@
           <a:lstStyle/>
           <a:p>
             <a:pPr>
-              <a:defRPr sz="2800" b="1">
-                <a:solidFill>
-                  <a:srgbClr val="1A1A1A"/>
-                </a:solidFill>
+              <a:defRPr sz="1200" b="0">
+                <a:solidFill>
+                  <a:srgbClr val="6B7280"/>
+                </a:solidFill>
+                <a:latin typeface="Segoe UI"/>
               </a:defRPr>
             </a:pPr>
             <a:r>
-              <a:t>Phase 1: the setting (piano, aligned MIDI)</a:t>
+              <a:t>9</a:t>
             </a:r>
           </a:p>
         </p:txBody>
@@ -8000,8 +9842,8 @@
         </p:nvSpPr>
         <p:spPr>
           <a:xfrm>
-            <a:off x="822960" y="1097280"/>
-            <a:ext cx="10515600" cy="640080"/>
+            <a:off x="411480" y="228600"/>
+            <a:ext cx="11338560" cy="685800"/>
           </a:xfrm>
           <a:prstGeom prst="rect">
             <a:avLst/>
@@ -8015,10 +9857,91 @@
           <a:lstStyle/>
           <a:p>
             <a:pPr>
-              <a:defRPr sz="2000">
+              <a:defRPr sz="2800" b="1">
+                <a:solidFill>
+                  <a:srgbClr val="1A1A1A"/>
+                </a:solidFill>
+                <a:latin typeface="Segoe UI"/>
+              </a:defRPr>
+            </a:pPr>
+            <a:r>
+              <a:t>Phase 1: the setting (piano, aligned MIDI)</a:t>
+            </a:r>
+          </a:p>
+        </p:txBody>
+      </p:sp>
+      <p:sp>
+        <p:nvSpPr>
+          <p:cNvPr id="4" name="Rectangle 3"/>
+          <p:cNvSpPr/>
+          <p:nvPr/>
+        </p:nvSpPr>
+        <p:spPr>
+          <a:xfrm>
+            <a:off x="457200" y="896112"/>
+            <a:ext cx="11247120" cy="27940"/>
+          </a:xfrm>
+          <a:prstGeom prst="rect">
+            <a:avLst/>
+          </a:prstGeom>
+          <a:solidFill>
+            <a:srgbClr val="0072B2"/>
+          </a:solidFill>
+          <a:ln>
+            <a:noFill/>
+          </a:ln>
+          <a:effectLst/>
+        </p:spPr>
+        <p:style>
+          <a:lnRef idx="1">
+            <a:schemeClr val="accent1"/>
+          </a:lnRef>
+          <a:fillRef idx="3">
+            <a:schemeClr val="accent1"/>
+          </a:fillRef>
+          <a:effectRef idx="2">
+            <a:schemeClr val="accent1"/>
+          </a:effectRef>
+          <a:fontRef idx="minor">
+            <a:schemeClr val="lt1"/>
+          </a:fontRef>
+        </p:style>
+        <p:txBody>
+          <a:bodyPr rtlCol="0" anchor="ctr"/>
+          <a:lstStyle/>
+          <a:p>
+            <a:pPr algn="ctr"/>
+          </a:p>
+        </p:txBody>
+      </p:sp>
+      <p:sp>
+        <p:nvSpPr>
+          <p:cNvPr id="5" name="TextBox 4"/>
+          <p:cNvSpPr txBox="1"/>
+          <p:nvPr/>
+        </p:nvSpPr>
+        <p:spPr>
+          <a:xfrm>
+            <a:off x="822960" y="1097280"/>
+            <a:ext cx="10515600" cy="640080"/>
+          </a:xfrm>
+          <a:prstGeom prst="rect">
+            <a:avLst/>
+          </a:prstGeom>
+          <a:noFill/>
+        </p:spPr>
+        <p:txBody>
+          <a:bodyPr wrap="none">
+            <a:spAutoFit/>
+          </a:bodyPr>
+          <a:lstStyle/>
+          <a:p>
+            <a:pPr>
+              <a:defRPr sz="2000" b="0">
                 <a:solidFill>
                   <a:srgbClr val="0072B2"/>
                 </a:solidFill>
+                <a:latin typeface="Segoe UI"/>
               </a:defRPr>
             </a:pPr>
             <a:r>
@@ -8029,7 +9952,7 @@
       </p:sp>
       <p:sp>
         <p:nvSpPr>
-          <p:cNvPr id="4" name="TextBox 3"/>
+          <p:cNvPr id="6" name="TextBox 5"/>
           <p:cNvSpPr txBox="1"/>
           <p:nvPr/>
         </p:nvSpPr>
@@ -8051,31 +9974,33 @@
           <a:p>
             <a:pPr>
               <a:spcAft>
-                <a:spcPts val="800"/>
+                <a:spcPts val="1000"/>
               </a:spcAft>
-              <a:defRPr sz="2000">
+              <a:defRPr sz="2000" b="0">
                 <a:solidFill>
                   <a:srgbClr val="1A1A1A"/>
                 </a:solidFill>
+                <a:latin typeface="Segoe UI"/>
               </a:defRPr>
             </a:pPr>
             <a:r>
-              <a:t>• A Disklavier records exactly what the pianist controlled: three variables per note, read directly, no estimation.</a:t>
+              <a:t>•  A Disklavier records exactly what the pianist controlled: three variables per note, read directly, no estimation.</a:t>
             </a:r>
           </a:p>
           <a:p>
             <a:pPr>
               <a:spcAft>
-                <a:spcPts val="800"/>
+                <a:spcPts val="1000"/>
               </a:spcAft>
-              <a:defRPr sz="2000">
+              <a:defRPr sz="2000" b="0">
                 <a:solidFill>
                   <a:srgbClr val="1A1A1A"/>
                 </a:solidFill>
+                <a:latin typeface="Segoe UI"/>
               </a:defRPr>
             </a:pPr>
             <a:r>
-              <a:t>• The question: on held-out notes, how good are the estimates, and can the error bars be trusted?</a:t>
+              <a:t>•  The question: on held-out notes, how good are the estimates, and can the error bars be trusted?</a:t>
             </a:r>
           </a:p>
         </p:txBody>

</xml_diff>